<commit_message>
Update Slide 1 to match official Hackathon template
</commit_message>
<xml_diff>
--- a/docs/presentation.pptx
+++ b/docs/presentation.pptx
@@ -2179,421 +2179,717 @@
       </p:grpSpPr>
       <p:sp>
         <p:nvSpPr>
-          <p:cNvPr id="2" name="Text 0"/>
-          <p:cNvSpPr txBox="1"/>
-          <p:nvPr/>
-        </p:nvSpPr>
-        <p:spPr>
-          <a:xfrm>
-            <a:off x="548640" y="822960"/>
-            <a:ext cx="8046720" cy="822960"/>
-          </a:xfrm>
-          <a:prstGeom prst="rect">
-            <a:avLst/>
-          </a:prstGeom>
-          <a:noFill/>
-          <a:ln/>
-        </p:spPr>
-        <p:txBody>
-          <a:bodyPr wrap="square" lIns="0" tIns="0" rIns="0" bIns="0" rtlCol="0" anchor="ctr"/>
-          <a:lstStyle/>
-          <a:p>
-            <a:pPr indent="0" marL="0">
-              <a:buNone/>
-            </a:pPr>
-            <a:r>
-              <a:rPr lang="en-US" sz="5400" b="1" dirty="0">
+          <p:cNvPr id="2" name="Rectangle 1"/>
+          <p:cNvSpPr/>
+          <p:nvPr/>
+        </p:nvSpPr>
+        <p:spPr>
+          <a:xfrm>
+            <a:off x="457200" y="457200"/>
+            <a:ext cx="4114800" cy="365760"/>
+          </a:xfrm>
+          <a:prstGeom prst="rect">
+            <a:avLst/>
+          </a:prstGeom>
+          <a:solidFill>
+            <a:srgbClr val="1E3C96"/>
+          </a:solidFill>
+          <a:ln>
+            <a:solidFill>
+              <a:srgbClr val="1E3C96"/>
+            </a:solidFill>
+          </a:ln>
+        </p:spPr>
+        <p:style>
+          <a:lnRef idx="1">
+            <a:schemeClr val="accent1"/>
+          </a:lnRef>
+          <a:fillRef idx="3">
+            <a:schemeClr val="accent1"/>
+          </a:fillRef>
+          <a:effectRef idx="2">
+            <a:schemeClr val="accent1"/>
+          </a:effectRef>
+          <a:fontRef idx="minor">
+            <a:schemeClr val="lt1"/>
+          </a:fontRef>
+        </p:style>
+        <p:txBody>
+          <a:bodyPr rtlCol="0" anchor="ctr"/>
+          <a:lstStyle/>
+          <a:p>
+            <a:pPr algn="ctr">
+              <a:defRPr b="1" sz="1000">
                 <a:solidFill>
                   <a:srgbClr val="FFFFFF"/>
                 </a:solidFill>
-                <a:latin typeface="Cambria" pitchFamily="34" charset="0"/>
-                <a:ea typeface="Cambria" pitchFamily="34" charset="-122"/>
-                <a:cs typeface="Cambria" pitchFamily="34" charset="-120"/>
-              </a:rPr>
-              <a:t>SENTINELRISK</a:t>
-            </a:r>
-            <a:endParaRPr lang="en-US" sz="5400" dirty="0"/>
-          </a:p>
-        </p:txBody>
-      </p:sp>
-      <p:sp>
-        <p:nvSpPr>
-          <p:cNvPr id="3" name="Text 1"/>
-          <p:cNvSpPr txBox="1"/>
-          <p:nvPr/>
-        </p:nvSpPr>
-        <p:spPr>
-          <a:xfrm>
-            <a:off x="548640" y="1691640"/>
-            <a:ext cx="6583680" cy="822960"/>
-          </a:xfrm>
-          <a:prstGeom prst="rect">
-            <a:avLst/>
-          </a:prstGeom>
-          <a:noFill/>
-          <a:ln/>
-        </p:spPr>
-        <p:txBody>
-          <a:bodyPr wrap="square" lIns="0" tIns="0" rIns="0" bIns="0" rtlCol="0" anchor="ctr"/>
-          <a:lstStyle/>
-          <a:p>
-            <a:pPr indent="0" marL="0">
-              <a:buNone/>
-            </a:pPr>
-            <a:r>
-              <a:rPr lang="en-US" sz="2000" dirty="0">
-                <a:solidFill>
-                  <a:srgbClr val="CBD5E1"/>
-                </a:solidFill>
-                <a:latin typeface="Calibri" pitchFamily="34" charset="0"/>
-                <a:ea typeface="Calibri" pitchFamily="34" charset="-122"/>
-                <a:cs typeface="Calibri" pitchFamily="34" charset="-120"/>
-              </a:rPr>
-              <a:t>Real-time AI/NLP risk engine that tilts your index before the market finishes reading the headline</a:t>
-            </a:r>
-            <a:endParaRPr lang="en-US" sz="2000" dirty="0"/>
-          </a:p>
-        </p:txBody>
-      </p:sp>
-      <p:sp>
-        <p:nvSpPr>
-          <p:cNvPr id="4" name="Shape 2"/>
+              </a:defRPr>
+            </a:pPr>
+            <a:r>
+              <a:t>S&amp;P GLOBAL &amp; CRISIL CAMPUS HACKATHON 2026</a:t>
+            </a:r>
+          </a:p>
+        </p:txBody>
+      </p:sp>
+      <p:sp>
+        <p:nvSpPr>
+          <p:cNvPr id="3" name="TextBox 2"/>
+          <p:cNvSpPr txBox="1"/>
+          <p:nvPr/>
+        </p:nvSpPr>
+        <p:spPr>
+          <a:xfrm>
+            <a:off x="457200" y="1097280"/>
+            <a:ext cx="8229600" cy="1371600"/>
+          </a:xfrm>
+          <a:prstGeom prst="rect">
+            <a:avLst/>
+          </a:prstGeom>
+          <a:noFill/>
+        </p:spPr>
+        <p:txBody>
+          <a:bodyPr wrap="none">
+            <a:spAutoFit/>
+          </a:bodyPr>
+          <a:lstStyle/>
+          <a:p>
+            <a:pPr>
+              <a:defRPr b="1" sz="2800">
+                <a:solidFill>
+                  <a:srgbClr val="FFFFFF"/>
+                </a:solidFill>
+              </a:defRPr>
+            </a:pPr>
+            <a:r>
+              <a:t>AI/NLP Financial Risk Engine &amp;</a:t>
+            </a:r>
+            <a:br/>
+          </a:p>
+          <a:p>
+            <a:pPr>
+              <a:defRPr b="1" sz="2800">
+                <a:solidFill>
+                  <a:srgbClr val="00C8C8"/>
+                </a:solidFill>
+              </a:defRPr>
+            </a:pPr>
+            <a:r>
+              <a:t>Tactical Index Rebalancing</a:t>
+            </a:r>
+          </a:p>
+        </p:txBody>
+      </p:sp>
+      <p:sp>
+        <p:nvSpPr>
+          <p:cNvPr id="4" name="TextBox 3"/>
+          <p:cNvSpPr txBox="1"/>
+          <p:nvPr/>
+        </p:nvSpPr>
+        <p:spPr>
+          <a:xfrm>
+            <a:off x="457200" y="2011680"/>
+            <a:ext cx="8229600" cy="457200"/>
+          </a:xfrm>
+          <a:prstGeom prst="rect">
+            <a:avLst/>
+          </a:prstGeom>
+          <a:noFill/>
+        </p:spPr>
+        <p:txBody>
+          <a:bodyPr wrap="none">
+            <a:spAutoFit/>
+          </a:bodyPr>
+          <a:lstStyle/>
+          <a:p>
+            <a:pPr>
+              <a:defRPr sz="1400">
+                <a:solidFill>
+                  <a:srgbClr val="B4B4B4"/>
+                </a:solidFill>
+              </a:defRPr>
+            </a:pPr>
+            <a:r>
+              <a:t>Module A: Tactical High-Frequency Stock Index Rebalancer</a:t>
+            </a:r>
+          </a:p>
+        </p:txBody>
+      </p:sp>
+      <p:sp>
+        <p:nvSpPr>
+          <p:cNvPr id="5" name="Rectangle 4"/>
           <p:cNvSpPr/>
           <p:nvPr/>
         </p:nvSpPr>
         <p:spPr>
           <a:xfrm>
-            <a:off x="548640" y="3200400"/>
-            <a:ext cx="2468880" cy="1234440"/>
-          </a:xfrm>
-          <a:prstGeom prst="roundRect">
-            <a:avLst>
-              <a:gd name="adj" fmla="val 8889"/>
-            </a:avLst>
-          </a:prstGeom>
-          <a:solidFill>
-            <a:srgbClr val="132642"/>
-          </a:solidFill>
+            <a:off x="457200" y="2743200"/>
+            <a:ext cx="4114800" cy="2286000"/>
+          </a:xfrm>
+          <a:prstGeom prst="rect">
+            <a:avLst/>
+          </a:prstGeom>
+          <a:noFill/>
           <a:ln w="12700">
             <a:solidFill>
-              <a:srgbClr val="1E3A5F"/>
+              <a:srgbClr val="323250"/>
             </a:solidFill>
-            <a:prstDash val="solid"/>
           </a:ln>
         </p:spPr>
-      </p:sp>
-      <p:sp>
-        <p:nvSpPr>
-          <p:cNvPr id="5" name="Text 3"/>
-          <p:cNvSpPr txBox="1"/>
-          <p:nvPr/>
-        </p:nvSpPr>
-        <p:spPr>
-          <a:xfrm>
-            <a:off x="731520" y="3291840"/>
-            <a:ext cx="2103120" cy="640080"/>
-          </a:xfrm>
-          <a:prstGeom prst="rect">
-            <a:avLst/>
-          </a:prstGeom>
-          <a:noFill/>
-          <a:ln/>
-        </p:spPr>
-        <p:txBody>
-          <a:bodyPr wrap="square" lIns="0" tIns="0" rIns="0" bIns="0" rtlCol="0" anchor="ctr"/>
-          <a:lstStyle/>
-          <a:p>
-            <a:pPr indent="0" marL="0">
-              <a:buNone/>
-            </a:pPr>
-            <a:r>
-              <a:rPr lang="en-US" sz="3400" b="1" dirty="0">
-                <a:solidFill>
-                  <a:srgbClr val="10B981"/>
-                </a:solidFill>
-                <a:latin typeface="Cambria" pitchFamily="34" charset="0"/>
-                <a:ea typeface="Cambria" pitchFamily="34" charset="-122"/>
-                <a:cs typeface="Cambria" pitchFamily="34" charset="-120"/>
-              </a:rPr>
-              <a:t>+7.69%</a:t>
-            </a:r>
-            <a:endParaRPr lang="en-US" sz="3400" dirty="0"/>
-          </a:p>
-        </p:txBody>
-      </p:sp>
-      <p:sp>
-        <p:nvSpPr>
-          <p:cNvPr id="6" name="Text 4"/>
-          <p:cNvSpPr txBox="1"/>
-          <p:nvPr/>
-        </p:nvSpPr>
-        <p:spPr>
-          <a:xfrm>
-            <a:off x="731520" y="3931920"/>
-            <a:ext cx="2103120" cy="365760"/>
-          </a:xfrm>
-          <a:prstGeom prst="rect">
-            <a:avLst/>
-          </a:prstGeom>
-          <a:noFill/>
-          <a:ln/>
-        </p:spPr>
-        <p:txBody>
-          <a:bodyPr wrap="square" lIns="0" tIns="0" rIns="0" bIns="0" rtlCol="0" anchor="ctr"/>
-          <a:lstStyle/>
-          <a:p>
-            <a:pPr indent="0" marL="0">
-              <a:buNone/>
-            </a:pPr>
-            <a:r>
-              <a:rPr lang="en-US" sz="1400" dirty="0">
-                <a:solidFill>
-                  <a:srgbClr val="CBD5E1"/>
-                </a:solidFill>
-                <a:latin typeface="Calibri" pitchFamily="34" charset="0"/>
-                <a:ea typeface="Calibri" pitchFamily="34" charset="-122"/>
-                <a:cs typeface="Calibri" pitchFamily="34" charset="-120"/>
-              </a:rPr>
-              <a:t>Total return vs 6.50% EW</a:t>
-            </a:r>
-            <a:endParaRPr lang="en-US" sz="1400" dirty="0"/>
-          </a:p>
-        </p:txBody>
-      </p:sp>
-      <p:sp>
-        <p:nvSpPr>
-          <p:cNvPr id="7" name="Shape 5"/>
+        <p:style>
+          <a:lnRef idx="1">
+            <a:schemeClr val="accent1"/>
+          </a:lnRef>
+          <a:fillRef idx="3">
+            <a:schemeClr val="accent1"/>
+          </a:fillRef>
+          <a:effectRef idx="2">
+            <a:schemeClr val="accent1"/>
+          </a:effectRef>
+          <a:fontRef idx="minor">
+            <a:schemeClr val="lt1"/>
+          </a:fontRef>
+        </p:style>
+        <p:txBody>
+          <a:bodyPr rtlCol="0" anchor="ctr"/>
+          <a:lstStyle/>
+          <a:p>
+            <a:pPr algn="ctr"/>
+          </a:p>
+        </p:txBody>
+      </p:sp>
+      <p:sp>
+        <p:nvSpPr>
+          <p:cNvPr id="6" name="TextBox 5"/>
+          <p:cNvSpPr txBox="1"/>
+          <p:nvPr/>
+        </p:nvSpPr>
+        <p:spPr>
+          <a:xfrm>
+            <a:off x="548640" y="2834640"/>
+            <a:ext cx="3931920" cy="365760"/>
+          </a:xfrm>
+          <a:prstGeom prst="rect">
+            <a:avLst/>
+          </a:prstGeom>
+          <a:noFill/>
+        </p:spPr>
+        <p:txBody>
+          <a:bodyPr wrap="none">
+            <a:spAutoFit/>
+          </a:bodyPr>
+          <a:lstStyle/>
+          <a:p>
+            <a:pPr>
+              <a:defRPr b="1" sz="1100">
+                <a:solidFill>
+                  <a:srgbClr val="00C8C8"/>
+                </a:solidFill>
+              </a:defRPr>
+            </a:pPr>
+            <a:r>
+              <a:t>CANDIDATE INFORMATION</a:t>
+            </a:r>
+          </a:p>
+        </p:txBody>
+      </p:sp>
+      <p:sp>
+        <p:nvSpPr>
+          <p:cNvPr id="7" name="TextBox 6"/>
+          <p:cNvSpPr txBox="1"/>
+          <p:nvPr/>
+        </p:nvSpPr>
+        <p:spPr>
+          <a:xfrm>
+            <a:off x="548640" y="3291840"/>
+            <a:ext cx="1371600" cy="365760"/>
+          </a:xfrm>
+          <a:prstGeom prst="rect">
+            <a:avLst/>
+          </a:prstGeom>
+          <a:noFill/>
+        </p:spPr>
+        <p:txBody>
+          <a:bodyPr wrap="none">
+            <a:spAutoFit/>
+          </a:bodyPr>
+          <a:lstStyle/>
+          <a:p>
+            <a:pPr>
+              <a:defRPr sz="1000">
+                <a:solidFill>
+                  <a:srgbClr val="B4B4B4"/>
+                </a:solidFill>
+              </a:defRPr>
+            </a:pPr>
+            <a:r>
+              <a:t>Candidate Name:</a:t>
+            </a:r>
+          </a:p>
+        </p:txBody>
+      </p:sp>
+      <p:sp>
+        <p:nvSpPr>
+          <p:cNvPr id="8" name="TextBox 7"/>
+          <p:cNvSpPr txBox="1"/>
+          <p:nvPr/>
+        </p:nvSpPr>
+        <p:spPr>
+          <a:xfrm>
+            <a:off x="1920240" y="3291840"/>
+            <a:ext cx="2560320" cy="365760"/>
+          </a:xfrm>
+          <a:prstGeom prst="rect">
+            <a:avLst/>
+          </a:prstGeom>
+          <a:noFill/>
+        </p:spPr>
+        <p:txBody>
+          <a:bodyPr wrap="none">
+            <a:spAutoFit/>
+          </a:bodyPr>
+          <a:lstStyle/>
+          <a:p>
+            <a:pPr>
+              <a:defRPr sz="1000" b="1">
+                <a:solidFill>
+                  <a:srgbClr val="FFFFFF"/>
+                </a:solidFill>
+              </a:defRPr>
+            </a:pPr>
+            <a:r>
+              <a:t>PRADEEP MODAK</a:t>
+            </a:r>
+          </a:p>
+        </p:txBody>
+      </p:sp>
+      <p:sp>
+        <p:nvSpPr>
+          <p:cNvPr id="9" name="TextBox 8"/>
+          <p:cNvSpPr txBox="1"/>
+          <p:nvPr/>
+        </p:nvSpPr>
+        <p:spPr>
+          <a:xfrm>
+            <a:off x="548640" y="3657600"/>
+            <a:ext cx="1371600" cy="365760"/>
+          </a:xfrm>
+          <a:prstGeom prst="rect">
+            <a:avLst/>
+          </a:prstGeom>
+          <a:noFill/>
+        </p:spPr>
+        <p:txBody>
+          <a:bodyPr wrap="none">
+            <a:spAutoFit/>
+          </a:bodyPr>
+          <a:lstStyle/>
+          <a:p>
+            <a:pPr>
+              <a:defRPr sz="1000">
+                <a:solidFill>
+                  <a:srgbClr val="B4B4B4"/>
+                </a:solidFill>
+              </a:defRPr>
+            </a:pPr>
+            <a:r>
+              <a:t>College Email ID:</a:t>
+            </a:r>
+          </a:p>
+        </p:txBody>
+      </p:sp>
+      <p:sp>
+        <p:nvSpPr>
+          <p:cNvPr id="10" name="TextBox 9"/>
+          <p:cNvSpPr txBox="1"/>
+          <p:nvPr/>
+        </p:nvSpPr>
+        <p:spPr>
+          <a:xfrm>
+            <a:off x="1920240" y="3657600"/>
+            <a:ext cx="2560320" cy="365760"/>
+          </a:xfrm>
+          <a:prstGeom prst="rect">
+            <a:avLst/>
+          </a:prstGeom>
+          <a:noFill/>
+        </p:spPr>
+        <p:txBody>
+          <a:bodyPr wrap="none">
+            <a:spAutoFit/>
+          </a:bodyPr>
+          <a:lstStyle/>
+          <a:p>
+            <a:pPr>
+              <a:defRPr sz="1000" b="1">
+                <a:solidFill>
+                  <a:srgbClr val="FFFFFF"/>
+                </a:solidFill>
+              </a:defRPr>
+            </a:pPr>
+            <a:r>
+              <a:t>2023ugcm026@nitjsr.ac.in</a:t>
+            </a:r>
+          </a:p>
+        </p:txBody>
+      </p:sp>
+      <p:sp>
+        <p:nvSpPr>
+          <p:cNvPr id="11" name="TextBox 10"/>
+          <p:cNvSpPr txBox="1"/>
+          <p:nvPr/>
+        </p:nvSpPr>
+        <p:spPr>
+          <a:xfrm>
+            <a:off x="548640" y="4023360"/>
+            <a:ext cx="1371600" cy="365760"/>
+          </a:xfrm>
+          <a:prstGeom prst="rect">
+            <a:avLst/>
+          </a:prstGeom>
+          <a:noFill/>
+        </p:spPr>
+        <p:txBody>
+          <a:bodyPr wrap="none">
+            <a:spAutoFit/>
+          </a:bodyPr>
+          <a:lstStyle/>
+          <a:p>
+            <a:pPr>
+              <a:defRPr sz="1000">
+                <a:solidFill>
+                  <a:srgbClr val="B4B4B4"/>
+                </a:solidFill>
+              </a:defRPr>
+            </a:pPr>
+            <a:r>
+              <a:t>College / Campus:</a:t>
+            </a:r>
+          </a:p>
+        </p:txBody>
+      </p:sp>
+      <p:sp>
+        <p:nvSpPr>
+          <p:cNvPr id="12" name="TextBox 11"/>
+          <p:cNvSpPr txBox="1"/>
+          <p:nvPr/>
+        </p:nvSpPr>
+        <p:spPr>
+          <a:xfrm>
+            <a:off x="1920240" y="4023360"/>
+            <a:ext cx="2560320" cy="365760"/>
+          </a:xfrm>
+          <a:prstGeom prst="rect">
+            <a:avLst/>
+          </a:prstGeom>
+          <a:noFill/>
+        </p:spPr>
+        <p:txBody>
+          <a:bodyPr wrap="none">
+            <a:spAutoFit/>
+          </a:bodyPr>
+          <a:lstStyle/>
+          <a:p>
+            <a:pPr>
+              <a:defRPr sz="1000" b="1">
+                <a:solidFill>
+                  <a:srgbClr val="FFFFFF"/>
+                </a:solidFill>
+              </a:defRPr>
+            </a:pPr>
+            <a:r>
+              <a:t>NIT JAMSHEDPUR</a:t>
+            </a:r>
+          </a:p>
+        </p:txBody>
+      </p:sp>
+      <p:sp>
+        <p:nvSpPr>
+          <p:cNvPr id="13" name="TextBox 12"/>
+          <p:cNvSpPr txBox="1"/>
+          <p:nvPr/>
+        </p:nvSpPr>
+        <p:spPr>
+          <a:xfrm>
+            <a:off x="548640" y="4389120"/>
+            <a:ext cx="1371600" cy="365760"/>
+          </a:xfrm>
+          <a:prstGeom prst="rect">
+            <a:avLst/>
+          </a:prstGeom>
+          <a:noFill/>
+        </p:spPr>
+        <p:txBody>
+          <a:bodyPr wrap="none">
+            <a:spAutoFit/>
+          </a:bodyPr>
+          <a:lstStyle/>
+          <a:p>
+            <a:pPr>
+              <a:defRPr sz="1000">
+                <a:solidFill>
+                  <a:srgbClr val="B4B4B4"/>
+                </a:solidFill>
+              </a:defRPr>
+            </a:pPr>
+            <a:r>
+              <a:t>Track / Module:</a:t>
+            </a:r>
+          </a:p>
+        </p:txBody>
+      </p:sp>
+      <p:sp>
+        <p:nvSpPr>
+          <p:cNvPr id="14" name="TextBox 13"/>
+          <p:cNvSpPr txBox="1"/>
+          <p:nvPr/>
+        </p:nvSpPr>
+        <p:spPr>
+          <a:xfrm>
+            <a:off x="1920240" y="4389120"/>
+            <a:ext cx="2560320" cy="365760"/>
+          </a:xfrm>
+          <a:prstGeom prst="rect">
+            <a:avLst/>
+          </a:prstGeom>
+          <a:noFill/>
+        </p:spPr>
+        <p:txBody>
+          <a:bodyPr wrap="none">
+            <a:spAutoFit/>
+          </a:bodyPr>
+          <a:lstStyle/>
+          <a:p>
+            <a:pPr>
+              <a:defRPr sz="1000" b="1">
+                <a:solidFill>
+                  <a:srgbClr val="00C864"/>
+                </a:solidFill>
+              </a:defRPr>
+            </a:pPr>
+            <a:r>
+              <a:t>MODULE A (Tactical Index Rebalancing)</a:t>
+            </a:r>
+          </a:p>
+        </p:txBody>
+      </p:sp>
+      <p:sp>
+        <p:nvSpPr>
+          <p:cNvPr id="15" name="Rectangle 14"/>
           <p:cNvSpPr/>
           <p:nvPr/>
         </p:nvSpPr>
         <p:spPr>
           <a:xfrm>
-            <a:off x="3291840" y="3200400"/>
-            <a:ext cx="2468880" cy="1234440"/>
-          </a:xfrm>
-          <a:prstGeom prst="roundRect">
-            <a:avLst>
-              <a:gd name="adj" fmla="val 8889"/>
-            </a:avLst>
-          </a:prstGeom>
-          <a:solidFill>
-            <a:srgbClr val="132642"/>
-          </a:solidFill>
+            <a:off x="4754880" y="2743200"/>
+            <a:ext cx="3931920" cy="2286000"/>
+          </a:xfrm>
+          <a:prstGeom prst="rect">
+            <a:avLst/>
+          </a:prstGeom>
+          <a:noFill/>
           <a:ln w="12700">
             <a:solidFill>
-              <a:srgbClr val="1E3A5F"/>
+              <a:srgbClr val="323250"/>
             </a:solidFill>
-            <a:prstDash val="solid"/>
           </a:ln>
         </p:spPr>
-      </p:sp>
-      <p:sp>
-        <p:nvSpPr>
-          <p:cNvPr id="8" name="Text 6"/>
-          <p:cNvSpPr txBox="1"/>
-          <p:nvPr/>
-        </p:nvSpPr>
-        <p:spPr>
-          <a:xfrm>
-            <a:off x="3474720" y="3291840"/>
-            <a:ext cx="2103120" cy="640080"/>
-          </a:xfrm>
-          <a:prstGeom prst="rect">
-            <a:avLst/>
-          </a:prstGeom>
-          <a:noFill/>
-          <a:ln/>
-        </p:spPr>
-        <p:txBody>
-          <a:bodyPr wrap="square" lIns="0" tIns="0" rIns="0" bIns="0" rtlCol="0" anchor="ctr"/>
-          <a:lstStyle/>
-          <a:p>
-            <a:pPr indent="0" marL="0">
-              <a:buNone/>
-            </a:pPr>
-            <a:r>
-              <a:rPr lang="en-US" sz="3400" b="1" dirty="0">
-                <a:solidFill>
-                  <a:srgbClr val="F59E0B"/>
-                </a:solidFill>
-                <a:latin typeface="Cambria" pitchFamily="34" charset="0"/>
-                <a:ea typeface="Cambria" pitchFamily="34" charset="-122"/>
-                <a:cs typeface="Cambria" pitchFamily="34" charset="-120"/>
-              </a:rPr>
-              <a:t>2.16</a:t>
-            </a:r>
-            <a:endParaRPr lang="en-US" sz="3400" dirty="0"/>
-          </a:p>
-        </p:txBody>
-      </p:sp>
-      <p:sp>
-        <p:nvSpPr>
-          <p:cNvPr id="9" name="Text 7"/>
-          <p:cNvSpPr txBox="1"/>
-          <p:nvPr/>
-        </p:nvSpPr>
-        <p:spPr>
-          <a:xfrm>
-            <a:off x="3474720" y="3931920"/>
-            <a:ext cx="2103120" cy="365760"/>
-          </a:xfrm>
-          <a:prstGeom prst="rect">
-            <a:avLst/>
-          </a:prstGeom>
-          <a:noFill/>
-          <a:ln/>
-        </p:spPr>
-        <p:txBody>
-          <a:bodyPr wrap="square" lIns="0" tIns="0" rIns="0" bIns="0" rtlCol="0" anchor="ctr"/>
-          <a:lstStyle/>
-          <a:p>
-            <a:pPr indent="0" marL="0">
-              <a:buNone/>
-            </a:pPr>
-            <a:r>
-              <a:rPr lang="en-US" sz="1400" dirty="0">
-                <a:solidFill>
-                  <a:srgbClr val="CBD5E1"/>
-                </a:solidFill>
-                <a:latin typeface="Calibri" pitchFamily="34" charset="0"/>
-                <a:ea typeface="Calibri" pitchFamily="34" charset="-122"/>
-                <a:cs typeface="Calibri" pitchFamily="34" charset="-120"/>
-              </a:rPr>
-              <a:t>Sharpe ratio</a:t>
-            </a:r>
-            <a:endParaRPr lang="en-US" sz="1400" dirty="0"/>
-          </a:p>
-        </p:txBody>
-      </p:sp>
-      <p:sp>
-        <p:nvSpPr>
-          <p:cNvPr id="10" name="Shape 8"/>
-          <p:cNvSpPr/>
-          <p:nvPr/>
-        </p:nvSpPr>
-        <p:spPr>
-          <a:xfrm>
-            <a:off x="6035040" y="3200400"/>
-            <a:ext cx="2468880" cy="1234440"/>
-          </a:xfrm>
-          <a:prstGeom prst="roundRect">
-            <a:avLst>
-              <a:gd name="adj" fmla="val 8889"/>
-            </a:avLst>
-          </a:prstGeom>
-          <a:solidFill>
-            <a:srgbClr val="132642"/>
-          </a:solidFill>
-          <a:ln w="12700">
-            <a:solidFill>
-              <a:srgbClr val="1E3A5F"/>
-            </a:solidFill>
-            <a:prstDash val="solid"/>
-          </a:ln>
-        </p:spPr>
-      </p:sp>
-      <p:sp>
-        <p:nvSpPr>
-          <p:cNvPr id="11" name="Text 9"/>
-          <p:cNvSpPr txBox="1"/>
-          <p:nvPr/>
-        </p:nvSpPr>
-        <p:spPr>
-          <a:xfrm>
-            <a:off x="6217920" y="3291840"/>
-            <a:ext cx="2103120" cy="640080"/>
-          </a:xfrm>
-          <a:prstGeom prst="rect">
-            <a:avLst/>
-          </a:prstGeom>
-          <a:noFill/>
-          <a:ln/>
-        </p:spPr>
-        <p:txBody>
-          <a:bodyPr wrap="square" lIns="0" tIns="0" rIns="0" bIns="0" rtlCol="0" anchor="ctr"/>
-          <a:lstStyle/>
-          <a:p>
-            <a:pPr indent="0" marL="0">
-              <a:buNone/>
-            </a:pPr>
-            <a:r>
-              <a:rPr lang="en-US" sz="3400" b="1" dirty="0">
-                <a:solidFill>
-                  <a:srgbClr val="EF4444"/>
-                </a:solidFill>
-                <a:latin typeface="Cambria" pitchFamily="34" charset="0"/>
-                <a:ea typeface="Cambria" pitchFamily="34" charset="-122"/>
-                <a:cs typeface="Cambria" pitchFamily="34" charset="-120"/>
-              </a:rPr>
-              <a:t>-8.69%</a:t>
-            </a:r>
-            <a:endParaRPr lang="en-US" sz="3400" dirty="0"/>
-          </a:p>
-        </p:txBody>
-      </p:sp>
-      <p:sp>
-        <p:nvSpPr>
-          <p:cNvPr id="12" name="Text 10"/>
-          <p:cNvSpPr txBox="1"/>
-          <p:nvPr/>
-        </p:nvSpPr>
-        <p:spPr>
-          <a:xfrm>
-            <a:off x="6217920" y="3931920"/>
-            <a:ext cx="2103120" cy="365760"/>
-          </a:xfrm>
-          <a:prstGeom prst="rect">
-            <a:avLst/>
-          </a:prstGeom>
-          <a:noFill/>
-          <a:ln/>
-        </p:spPr>
-        <p:txBody>
-          <a:bodyPr wrap="square" lIns="0" tIns="0" rIns="0" bIns="0" rtlCol="0" anchor="ctr"/>
-          <a:lstStyle/>
-          <a:p>
-            <a:pPr indent="0" marL="0">
-              <a:buNone/>
-            </a:pPr>
-            <a:r>
-              <a:rPr lang="en-US" sz="1400" dirty="0">
-                <a:solidFill>
-                  <a:srgbClr val="CBD5E1"/>
-                </a:solidFill>
-                <a:latin typeface="Calibri" pitchFamily="34" charset="0"/>
-                <a:ea typeface="Calibri" pitchFamily="34" charset="-122"/>
-                <a:cs typeface="Calibri" pitchFamily="34" charset="-120"/>
-              </a:rPr>
-              <a:t>Max drawdown</a:t>
-            </a:r>
-            <a:endParaRPr lang="en-US" sz="1400" dirty="0"/>
-          </a:p>
-        </p:txBody>
-      </p:sp>
-      <p:pic>
-        <p:nvPicPr>
-          <p:cNvPr id="13" name="Image 0" descr="preencoded.png">    </p:cNvPr>
-          <p:cNvPicPr>
-            <a:picLocks noChangeAspect="1"/>
-          </p:cNvPicPr>
-          <p:nvPr/>
-        </p:nvPicPr>
-        <p:blipFill>
-          <a:blip r:embed="rId1"/>
-          <a:stretch>
-            <a:fillRect/>
-          </a:stretch>
-        </p:blipFill>
-        <p:spPr>
-          <a:xfrm>
-            <a:off x="7818120" y="731520"/>
-            <a:ext cx="822960" cy="822960"/>
-          </a:xfrm>
-          <a:prstGeom prst="rect">
-            <a:avLst/>
-          </a:prstGeom>
-        </p:spPr>
-      </p:pic>
+        <p:style>
+          <a:lnRef idx="1">
+            <a:schemeClr val="accent1"/>
+          </a:lnRef>
+          <a:fillRef idx="3">
+            <a:schemeClr val="accent1"/>
+          </a:fillRef>
+          <a:effectRef idx="2">
+            <a:schemeClr val="accent1"/>
+          </a:effectRef>
+          <a:fontRef idx="minor">
+            <a:schemeClr val="lt1"/>
+          </a:fontRef>
+        </p:style>
+        <p:txBody>
+          <a:bodyPr rtlCol="0" anchor="ctr"/>
+          <a:lstStyle/>
+          <a:p>
+            <a:pPr algn="ctr"/>
+          </a:p>
+        </p:txBody>
+      </p:sp>
+      <p:sp>
+        <p:nvSpPr>
+          <p:cNvPr id="16" name="TextBox 15"/>
+          <p:cNvSpPr txBox="1"/>
+          <p:nvPr/>
+        </p:nvSpPr>
+        <p:spPr>
+          <a:xfrm>
+            <a:off x="4846320" y="2834640"/>
+            <a:ext cx="3749039" cy="365760"/>
+          </a:xfrm>
+          <a:prstGeom prst="rect">
+            <a:avLst/>
+          </a:prstGeom>
+          <a:noFill/>
+        </p:spPr>
+        <p:txBody>
+          <a:bodyPr wrap="none">
+            <a:spAutoFit/>
+          </a:bodyPr>
+          <a:lstStyle/>
+          <a:p>
+            <a:pPr>
+              <a:defRPr b="1" sz="1100">
+                <a:solidFill>
+                  <a:srgbClr val="00C8C8"/>
+                </a:solidFill>
+              </a:defRPr>
+            </a:pPr>
+            <a:r>
+              <a:t>SYSTEM HIGHLIGHTS AT A GLANCE</a:t>
+            </a:r>
+          </a:p>
+        </p:txBody>
+      </p:sp>
+      <p:sp>
+        <p:nvSpPr>
+          <p:cNvPr id="17" name="TextBox 16"/>
+          <p:cNvSpPr txBox="1"/>
+          <p:nvPr/>
+        </p:nvSpPr>
+        <p:spPr>
+          <a:xfrm>
+            <a:off x="4846320" y="3291840"/>
+            <a:ext cx="3749039" cy="365760"/>
+          </a:xfrm>
+          <a:prstGeom prst="rect">
+            <a:avLst/>
+          </a:prstGeom>
+          <a:noFill/>
+        </p:spPr>
+        <p:txBody>
+          <a:bodyPr wrap="none">
+            <a:spAutoFit/>
+          </a:bodyPr>
+          <a:lstStyle/>
+          <a:p>
+            <a:pPr>
+              <a:defRPr sz="1000" b="1">
+                <a:solidFill>
+                  <a:srgbClr val="DCDCDC"/>
+                </a:solidFill>
+              </a:defRPr>
+            </a:pPr>
+            <a:r>
+              <a:t>- FinBERT NLP: P(pos) - P(neg) Sentiment Scoring [-1.0 to +1.0]</a:t>
+            </a:r>
+          </a:p>
+        </p:txBody>
+      </p:sp>
+      <p:sp>
+        <p:nvSpPr>
+          <p:cNvPr id="18" name="TextBox 17"/>
+          <p:cNvSpPr txBox="1"/>
+          <p:nvPr/>
+        </p:nvSpPr>
+        <p:spPr>
+          <a:xfrm>
+            <a:off x="4846320" y="3657600"/>
+            <a:ext cx="3749039" cy="365760"/>
+          </a:xfrm>
+          <a:prstGeom prst="rect">
+            <a:avLst/>
+          </a:prstGeom>
+          <a:noFill/>
+        </p:spPr>
+        <p:txBody>
+          <a:bodyPr wrap="none">
+            <a:spAutoFit/>
+          </a:bodyPr>
+          <a:lstStyle/>
+          <a:p>
+            <a:pPr>
+              <a:defRPr sz="1000" b="1">
+                <a:solidFill>
+                  <a:srgbClr val="DCDCDC"/>
+                </a:solidFill>
+              </a:defRPr>
+            </a:pPr>
+            <a:r>
+              <a:t>- Hybrid 6-Category Financial Event Taxonomy</a:t>
+            </a:r>
+          </a:p>
+        </p:txBody>
+      </p:sp>
+      <p:sp>
+        <p:nvSpPr>
+          <p:cNvPr id="19" name="TextBox 18"/>
+          <p:cNvSpPr txBox="1"/>
+          <p:nvPr/>
+        </p:nvSpPr>
+        <p:spPr>
+          <a:xfrm>
+            <a:off x="4846320" y="4023360"/>
+            <a:ext cx="3749039" cy="365760"/>
+          </a:xfrm>
+          <a:prstGeom prst="rect">
+            <a:avLst/>
+          </a:prstGeom>
+          <a:noFill/>
+        </p:spPr>
+        <p:txBody>
+          <a:bodyPr wrap="none">
+            <a:spAutoFit/>
+          </a:bodyPr>
+          <a:lstStyle/>
+          <a:p>
+            <a:pPr>
+              <a:defRPr sz="1000" b="1">
+                <a:solidFill>
+                  <a:srgbClr val="DCDCDC"/>
+                </a:solidFill>
+              </a:defRPr>
+            </a:pPr>
+            <a:r>
+              <a:t>- 15-Ticker S&amp;P 100 Live Entity Extraction</a:t>
+            </a:r>
+          </a:p>
+        </p:txBody>
+      </p:sp>
+      <p:sp>
+        <p:nvSpPr>
+          <p:cNvPr id="20" name="TextBox 19"/>
+          <p:cNvSpPr txBox="1"/>
+          <p:nvPr/>
+        </p:nvSpPr>
+        <p:spPr>
+          <a:xfrm>
+            <a:off x="4846320" y="4389120"/>
+            <a:ext cx="3749039" cy="365760"/>
+          </a:xfrm>
+          <a:prstGeom prst="rect">
+            <a:avLst/>
+          </a:prstGeom>
+          <a:noFill/>
+        </p:spPr>
+        <p:txBody>
+          <a:bodyPr wrap="none">
+            <a:spAutoFit/>
+          </a:bodyPr>
+          <a:lstStyle/>
+          <a:p>
+            <a:pPr>
+              <a:defRPr sz="1000" b="1">
+                <a:solidFill>
+                  <a:srgbClr val="DCDCDC"/>
+                </a:solidFill>
+              </a:defRPr>
+            </a:pPr>
+            <a:r>
+              <a:t>- Autonomous Rebalancing with Water-Filling Risk Bounds</a:t>
+            </a:r>
+          </a:p>
+        </p:txBody>
+      </p:sp>
     </p:spTree>
   </p:cSld>
   <p:clrMapOvr>

</xml_diff>

<commit_message>
Update presentation Slide 1 and add complete project zip archive
- Redesigned Slide 1 in docs/presentation.pptx to match the official S&P Hackathon template, including candidate details and system highlights.
- Packaged the entire repository into complete_project.zip for direct submission.
</commit_message>
<xml_diff>
--- a/docs/presentation.pptx
+++ b/docs/presentation.pptx
@@ -4,6 +4,9 @@
   <p:sldMasterIdLst>
     <p:sldMasterId id="2147483648" r:id="rId1"/>
   </p:sldMasterIdLst>
+  <p:notesMasterIdLst>
+    <p:notesMasterId r:id="rId11"/>
+  </p:notesMasterIdLst>
   <p:sldIdLst>
     <p:sldId id="256" r:id="rId2"/>
     <p:sldId id="257" r:id="rId3"/>
@@ -15,10 +18,7 @@
     <p:sldId id="263" r:id="rId9"/>
     <p:sldId id="264" r:id="rId10"/>
   </p:sldIdLst>
-  <p:notesMasterIdLst>
-    <p:notesMasterId r:id="rId11"/>
-  </p:notesMasterIdLst>
-  <p:sldSz cx="9144000" cy="5143500"/>
+  <p:sldSz cx="9144000" cy="5143500" type="screen16x9"/>
   <p:notesSz cx="5143500" cy="9144000"/>
   <p:defaultTextStyle>
     <a:lvl1pPr marL="0" algn="l" defTabSz="914400" rtl="0" eaLnBrk="1" latinLnBrk="0" hangingPunct="1">
@@ -112,13 +112,20 @@
       </a:defRPr>
     </a:lvl9pPr>
   </p:defaultTextStyle>
+  <p:extLst>
+    <p:ext uri="{EFAFB233-063F-42B5-8137-9DF3F51BA10A}">
+      <p15:sldGuideLst xmlns:p15="http://schemas.microsoft.com/office/powerpoint/2012/main"/>
+    </p:ext>
+  </p:extLst>
 </p:presentation>
 </file>
 
 <file path=ppt/charts/chart1.xml><?xml version="1.0" encoding="utf-8"?>
-<c:chartSpace xmlns:c="http://schemas.openxmlformats.org/drawingml/2006/chart" xmlns:a="http://schemas.openxmlformats.org/drawingml/2006/main" xmlns:r="http://schemas.openxmlformats.org/officeDocument/2006/relationships">
+<c:chartSpace xmlns:c="http://schemas.openxmlformats.org/drawingml/2006/chart" xmlns:a="http://schemas.openxmlformats.org/drawingml/2006/main" xmlns:r="http://schemas.openxmlformats.org/officeDocument/2006/relationships" xmlns:c16r2="http://schemas.microsoft.com/office/drawing/2015/06/chart">
   <c:date1904 val="0"/>
+  <c:lang val="en-US"/>
   <c:roundedCorners val="1"/>
+  <c:style val="2"/>
   <c:chart>
     <c:autoTitleDeleted val="1"/>
     <c:plotArea>
@@ -168,6 +175,11 @@
               </a:ln>
               <a:effectLst/>
             </c:spPr>
+            <c:extLst>
+              <c:ext xmlns:c16="http://schemas.microsoft.com/office/drawing/2014/chart" uri="{C3380CC4-5D6E-409C-BE32-E72D297353CC}">
+                <c16:uniqueId val="{00000001-9365-4F5D-84A4-5FD82C7B1DDC}"/>
+              </c:ext>
+            </c:extLst>
           </c:dPt>
           <c:dPt>
             <c:idx val="1"/>
@@ -185,6 +197,11 @@
               </a:ln>
               <a:effectLst/>
             </c:spPr>
+            <c:extLst>
+              <c:ext xmlns:c16="http://schemas.microsoft.com/office/drawing/2014/chart" uri="{C3380CC4-5D6E-409C-BE32-E72D297353CC}">
+                <c16:uniqueId val="{00000003-9365-4F5D-84A4-5FD82C7B1DDC}"/>
+              </c:ext>
+            </c:extLst>
           </c:dPt>
           <c:dPt>
             <c:idx val="2"/>
@@ -202,6 +219,11 @@
               </a:ln>
               <a:effectLst/>
             </c:spPr>
+            <c:extLst>
+              <c:ext xmlns:c16="http://schemas.microsoft.com/office/drawing/2014/chart" uri="{C3380CC4-5D6E-409C-BE32-E72D297353CC}">
+                <c16:uniqueId val="{00000005-9365-4F5D-84A4-5FD82C7B1DDC}"/>
+              </c:ext>
+            </c:extLst>
           </c:dPt>
           <c:dLbls>
             <c:dLbl>
@@ -220,6 +242,7 @@
                       <a:latin typeface="Calibri"/>
                     </a:defRPr>
                   </a:pPr>
+                  <a:endParaRPr lang="en-US"/>
                 </a:p>
               </c:txPr>
               <c:showLegendKey val="0"/>
@@ -228,6 +251,12 @@
               <c:showSerName val="0"/>
               <c:showPercent val="1"/>
               <c:showBubbleSize val="0"/>
+              <c:extLst>
+                <c:ext xmlns:c15="http://schemas.microsoft.com/office/drawing/2012/chart" uri="{CE6537A1-D6FC-4f65-9D91-7224C49458BB}"/>
+                <c:ext xmlns:c16="http://schemas.microsoft.com/office/drawing/2014/chart" uri="{C3380CC4-5D6E-409C-BE32-E72D297353CC}">
+                  <c16:uniqueId val="{00000001-9365-4F5D-84A4-5FD82C7B1DDC}"/>
+                </c:ext>
+              </c:extLst>
             </c:dLbl>
             <c:dLbl>
               <c:idx val="1"/>
@@ -245,6 +274,7 @@
                       <a:latin typeface="Calibri"/>
                     </a:defRPr>
                   </a:pPr>
+                  <a:endParaRPr lang="en-US"/>
                 </a:p>
               </c:txPr>
               <c:showLegendKey val="0"/>
@@ -253,6 +283,12 @@
               <c:showSerName val="0"/>
               <c:showPercent val="1"/>
               <c:showBubbleSize val="0"/>
+              <c:extLst>
+                <c:ext xmlns:c15="http://schemas.microsoft.com/office/drawing/2012/chart" uri="{CE6537A1-D6FC-4f65-9D91-7224C49458BB}"/>
+                <c:ext xmlns:c16="http://schemas.microsoft.com/office/drawing/2014/chart" uri="{C3380CC4-5D6E-409C-BE32-E72D297353CC}">
+                  <c16:uniqueId val="{00000003-9365-4F5D-84A4-5FD82C7B1DDC}"/>
+                </c:ext>
+              </c:extLst>
             </c:dLbl>
             <c:dLbl>
               <c:idx val="2"/>
@@ -270,6 +306,7 @@
                       <a:latin typeface="Calibri"/>
                     </a:defRPr>
                   </a:pPr>
+                  <a:endParaRPr lang="en-US"/>
                 </a:p>
               </c:txPr>
               <c:showLegendKey val="0"/>
@@ -278,8 +315,21 @@
               <c:showSerName val="0"/>
               <c:showPercent val="1"/>
               <c:showBubbleSize val="0"/>
+              <c:extLst>
+                <c:ext xmlns:c15="http://schemas.microsoft.com/office/drawing/2012/chart" uri="{CE6537A1-D6FC-4f65-9D91-7224C49458BB}"/>
+                <c:ext xmlns:c16="http://schemas.microsoft.com/office/drawing/2014/chart" uri="{C3380CC4-5D6E-409C-BE32-E72D297353CC}">
+                  <c16:uniqueId val="{00000005-9365-4F5D-84A4-5FD82C7B1DDC}"/>
+                </c:ext>
+              </c:extLst>
             </c:dLbl>
             <c:numFmt formatCode="0%" sourceLinked="0"/>
+            <c:spPr>
+              <a:noFill/>
+              <a:ln>
+                <a:noFill/>
+              </a:ln>
+              <a:effectLst/>
+            </c:spPr>
             <c:txPr>
               <a:bodyPr/>
               <a:lstStyle/>
@@ -292,6 +342,7 @@
                     <a:latin typeface="Arial"/>
                   </a:defRPr>
                 </a:pPr>
+                <a:endParaRPr lang="en-US"/>
               </a:p>
             </c:txPr>
             <c:showLegendKey val="0"/>
@@ -301,6 +352,9 @@
             <c:showPercent val="1"/>
             <c:showBubbleSize val="0"/>
             <c:showLeaderLines val="0"/>
+            <c:extLst>
+              <c:ext xmlns:c15="http://schemas.microsoft.com/office/drawing/2012/chart" uri="{CE6537A1-D6FC-4f65-9D91-7224C49458BB}"/>
+            </c:extLst>
           </c:dLbls>
           <c:cat>
             <c:strRef>
@@ -323,6 +377,7 @@
             <c:numRef>
               <c:f>Sheet1!$B$2:$B$4</c:f>
               <c:numCache>
+                <c:formatCode>General</c:formatCode>
                 <c:ptCount val="3"/>
                 <c:pt idx="0">
                   <c:v>40</c:v>
@@ -336,7 +391,21 @@
               </c:numCache>
             </c:numRef>
           </c:val>
+          <c:extLst>
+            <c:ext xmlns:c16="http://schemas.microsoft.com/office/drawing/2014/chart" uri="{C3380CC4-5D6E-409C-BE32-E72D297353CC}">
+              <c16:uniqueId val="{00000006-9365-4F5D-84A4-5FD82C7B1DDC}"/>
+            </c:ext>
+          </c:extLst>
         </c:ser>
+        <c:dLbls>
+          <c:showLegendKey val="0"/>
+          <c:showVal val="0"/>
+          <c:showCatName val="0"/>
+          <c:showSerName val="0"/>
+          <c:showPercent val="0"/>
+          <c:showBubbleSize val="0"/>
+          <c:showLeaderLines val="0"/>
+        </c:dLbls>
         <c:firstSliceAng val="0"/>
         <c:holeSize val="55"/>
       </c:doughnutChart>
@@ -370,6 +439,7 @@
     </c:legend>
     <c:plotVisOnly val="1"/>
     <c:dispBlanksAs val="span"/>
+    <c:showDLblsOverMax val="1"/>
   </c:chart>
   <c:spPr>
     <a:noFill/>
@@ -385,9 +455,11 @@
 </file>
 
 <file path=ppt/charts/chart2.xml><?xml version="1.0" encoding="utf-8"?>
-<c:chartSpace xmlns:c="http://schemas.openxmlformats.org/drawingml/2006/chart" xmlns:a="http://schemas.openxmlformats.org/drawingml/2006/main" xmlns:r="http://schemas.openxmlformats.org/officeDocument/2006/relationships">
+<c:chartSpace xmlns:c="http://schemas.openxmlformats.org/drawingml/2006/chart" xmlns:a="http://schemas.openxmlformats.org/drawingml/2006/main" xmlns:r="http://schemas.openxmlformats.org/officeDocument/2006/relationships" xmlns:c16r2="http://schemas.microsoft.com/office/drawing/2015/06/chart">
   <c:date1904 val="0"/>
+  <c:lang val="en-US"/>
   <c:roundedCorners val="1"/>
+  <c:style val="2"/>
   <c:chart>
     <c:autoTitleDeleted val="1"/>
     <c:plotArea>
@@ -419,18 +491,26 @@
           <c:invertIfNegative val="0"/>
           <c:dLbls>
             <c:numFmt formatCode="0.00&quot;%&quot;" sourceLinked="0"/>
+            <c:spPr>
+              <a:noFill/>
+              <a:ln>
+                <a:noFill/>
+              </a:ln>
+              <a:effectLst/>
+            </c:spPr>
             <c:txPr>
               <a:bodyPr/>
               <a:lstStyle/>
               <a:p>
                 <a:pPr>
-                  <a:defRPr b="1" i="0" strike="noStrike" sz="1400" u="none">
+                  <a:defRPr sz="1400" b="1" i="0" u="none" strike="noStrike">
                     <a:solidFill>
                       <a:srgbClr val="0F172A"/>
                     </a:solidFill>
                     <a:latin typeface="Calibri"/>
                   </a:defRPr>
                 </a:pPr>
+                <a:endParaRPr lang="en-US"/>
               </a:p>
             </c:txPr>
             <c:showLegendKey val="0"/>
@@ -440,19 +520,22 @@
             <c:showPercent val="0"/>
             <c:showBubbleSize val="0"/>
             <c:showLeaderLines val="0"/>
+            <c:extLst>
+              <c:ext xmlns:c15="http://schemas.microsoft.com/office/drawing/2012/chart" uri="{CE6537A1-D6FC-4f65-9D91-7224C49458BB}">
+                <c15:showLeaderLines val="0"/>
+              </c:ext>
+            </c:extLst>
           </c:dLbls>
           <c:cat>
-            <c:multiLvlStrRef>
+            <c:strRef>
               <c:f>Sheet1!$A$2:$A$2</c:f>
-              <c:multiLvlStrCache>
+              <c:strCache>
                 <c:ptCount val="1"/>
-                <c:lvl>
-                  <c:pt idx="0">
-                    <c:v>Total return (%)</c:v>
-                  </c:pt>
-                </c:lvl>
-              </c:multiLvlStrCache>
-            </c:multiLvlStrRef>
+                <c:pt idx="0">
+                  <c:v>Total return (%)</c:v>
+                </c:pt>
+              </c:strCache>
+            </c:strRef>
           </c:cat>
           <c:val>
             <c:numRef>
@@ -466,6 +549,11 @@
               </c:numCache>
             </c:numRef>
           </c:val>
+          <c:extLst>
+            <c:ext xmlns:c16="http://schemas.microsoft.com/office/drawing/2014/chart" uri="{C3380CC4-5D6E-409C-BE32-E72D297353CC}">
+              <c16:uniqueId val="{00000000-1E38-48A7-9F0D-AD1C5CDCE65D}"/>
+            </c:ext>
+          </c:extLst>
         </c:ser>
         <c:ser>
           <c:idx val="1"/>
@@ -490,18 +578,26 @@
           <c:invertIfNegative val="0"/>
           <c:dLbls>
             <c:numFmt formatCode="0.00&quot;%&quot;" sourceLinked="0"/>
+            <c:spPr>
+              <a:noFill/>
+              <a:ln>
+                <a:noFill/>
+              </a:ln>
+              <a:effectLst/>
+            </c:spPr>
             <c:txPr>
               <a:bodyPr/>
               <a:lstStyle/>
               <a:p>
                 <a:pPr>
-                  <a:defRPr b="1" i="0" strike="noStrike" sz="1400" u="none">
+                  <a:defRPr sz="1400" b="1" i="0" u="none" strike="noStrike">
                     <a:solidFill>
                       <a:srgbClr val="0F172A"/>
                     </a:solidFill>
                     <a:latin typeface="Calibri"/>
                   </a:defRPr>
                 </a:pPr>
+                <a:endParaRPr lang="en-US"/>
               </a:p>
             </c:txPr>
             <c:showLegendKey val="0"/>
@@ -511,19 +607,22 @@
             <c:showPercent val="0"/>
             <c:showBubbleSize val="0"/>
             <c:showLeaderLines val="0"/>
+            <c:extLst>
+              <c:ext xmlns:c15="http://schemas.microsoft.com/office/drawing/2012/chart" uri="{CE6537A1-D6FC-4f65-9D91-7224C49458BB}">
+                <c15:showLeaderLines val="0"/>
+              </c:ext>
+            </c:extLst>
           </c:dLbls>
           <c:cat>
-            <c:multiLvlStrRef>
+            <c:strRef>
               <c:f>Sheet1!$A$2:$A$2</c:f>
-              <c:multiLvlStrCache>
+              <c:strCache>
                 <c:ptCount val="1"/>
-                <c:lvl>
-                  <c:pt idx="0">
-                    <c:v>Total return (%)</c:v>
-                  </c:pt>
-                </c:lvl>
-              </c:multiLvlStrCache>
-            </c:multiLvlStrRef>
+                <c:pt idx="0">
+                  <c:v>Total return (%)</c:v>
+                </c:pt>
+              </c:strCache>
+            </c:strRef>
           </c:cat>
           <c:val>
             <c:numRef>
@@ -537,36 +636,23 @@
               </c:numCache>
             </c:numRef>
           </c:val>
+          <c:extLst>
+            <c:ext xmlns:c16="http://schemas.microsoft.com/office/drawing/2014/chart" uri="{C3380CC4-5D6E-409C-BE32-E72D297353CC}">
+              <c16:uniqueId val="{00000001-1E38-48A7-9F0D-AD1C5CDCE65D}"/>
+            </c:ext>
+          </c:extLst>
         </c:ser>
         <c:dLbls>
-          <c:numFmt formatCode="0.00&quot;%&quot;" sourceLinked="0"/>
-          <c:txPr>
-            <a:bodyPr/>
-            <a:lstStyle/>
-            <a:p>
-              <a:pPr>
-                <a:defRPr b="1" i="0" strike="noStrike" sz="1400" u="none">
-                  <a:solidFill>
-                    <a:srgbClr val="0F172A"/>
-                  </a:solidFill>
-                  <a:latin typeface="Calibri"/>
-                </a:defRPr>
-              </a:pPr>
-            </a:p>
-          </c:txPr>
           <c:showLegendKey val="0"/>
           <c:showVal val="1"/>
           <c:showCatName val="0"/>
           <c:showSerName val="0"/>
           <c:showPercent val="0"/>
           <c:showBubbleSize val="0"/>
-          <c:showLeaderLines val="0"/>
         </c:dLbls>
         <c:gapWidth val="60"/>
-        <c:overlap val="0"/>
         <c:axId val="2094734554"/>
         <c:axId val="2094734552"/>
-        <c:axId val="2094734556"/>
       </c:barChart>
       <c:catAx>
         <c:axId val="2094734554"/>
@@ -607,6 +693,7 @@
         <c:crosses val="autoZero"/>
         <c:auto val="1"/>
         <c:lblAlgn val="ctr"/>
+        <c:lblOffset val="100"/>
         <c:noMultiLvlLbl val="1"/>
       </c:catAx>
       <c:valAx>
@@ -691,6 +778,7 @@
     </c:legend>
     <c:plotVisOnly val="1"/>
     <c:dispBlanksAs val="span"/>
+    <c:showDLblsOverMax val="1"/>
   </c:chart>
   <c:spPr>
     <a:noFill/>
@@ -727,234 +815,10 @@
           <a:chExt cx="0" cy="0"/>
         </a:xfrm>
       </p:grpSpPr>
-      <p:sp>
-        <p:nvSpPr>
-          <p:cNvPr id="2" name="Header Placeholder 1"/>
-          <p:cNvSpPr>
-            <a:spLocks noGrp="1"/>
-          </p:cNvSpPr>
-          <p:nvPr>
-            <p:ph type="hdr" sz="quarter"/>
-          </p:nvPr>
-        </p:nvSpPr>
-        <p:spPr>
-          <a:xfrm>
-            <a:off x="0" y="0"/>
-            <a:ext cx="2971800" cy="458788"/>
-          </a:xfrm>
-          <a:prstGeom prst="rect">
-            <a:avLst/>
-          </a:prstGeom>
-        </p:spPr>
-        <p:txBody>
-          <a:bodyPr vert="horz" lIns="91440" tIns="45720" rIns="91440" bIns="45720" rtlCol="0"/>
-          <a:lstStyle>
-            <a:lvl1pPr algn="l">
-              <a:defRPr sz="1200"/>
-            </a:lvl1pPr>
-          </a:lstStyle>
-          <a:p>
-            <a:endParaRPr lang="en-US"/>
-          </a:p>
-        </p:txBody>
-      </p:sp>
-      <p:sp>
-        <p:nvSpPr>
-          <p:cNvPr id="3" name="Date Placeholder 2"/>
-          <p:cNvSpPr>
-            <a:spLocks noGrp="1"/>
-          </p:cNvSpPr>
-          <p:nvPr>
-            <p:ph type="dt" idx="1"/>
-          </p:nvPr>
-        </p:nvSpPr>
-        <p:spPr>
-          <a:xfrm>
-            <a:off x="3884613" y="0"/>
-            <a:ext cx="2971800" cy="458788"/>
-          </a:xfrm>
-          <a:prstGeom prst="rect">
-            <a:avLst/>
-          </a:prstGeom>
-        </p:spPr>
-        <p:txBody>
-          <a:bodyPr vert="horz" lIns="91440" tIns="45720" rIns="91440" bIns="45720" rtlCol="0"/>
-          <a:lstStyle>
-            <a:lvl1pPr algn="r">
-              <a:defRPr sz="1200"/>
-            </a:lvl1pPr>
-          </a:lstStyle>
-          <a:p>
-            <a:fld id="{5282F153-3F37-0F45-9E97-73ACFA13230C}" type="datetimeFigureOut">
-              <a:rPr lang="en-US"/>
-              <a:t>7/23/19</a:t>
-            </a:fld>
-            <a:endParaRPr lang="en-US"/>
-          </a:p>
-        </p:txBody>
-      </p:sp>
-      <p:sp>
-        <p:nvSpPr>
-          <p:cNvPr id="4" name="Slide Image Placeholder 3"/>
-          <p:cNvSpPr>
-            <a:spLocks noGrp="1" noRot="1" noChangeAspect="1"/>
-          </p:cNvSpPr>
-          <p:nvPr>
-            <p:ph type="sldImg" idx="2"/>
-          </p:nvPr>
-        </p:nvSpPr>
-        <p:spPr>
-          <a:xfrm>
-            <a:off x="685800" y="1143000"/>
-            <a:ext cx="5486400" cy="3086100"/>
-          </a:xfrm>
-          <a:prstGeom prst="rect">
-            <a:avLst/>
-          </a:prstGeom>
-          <a:noFill/>
-          <a:ln w="12700">
-            <a:solidFill>
-              <a:prstClr val="black"/>
-            </a:solidFill>
-          </a:ln>
-        </p:spPr>
-        <p:txBody>
-          <a:bodyPr vert="horz" lIns="91440" tIns="45720" rIns="91440" bIns="45720" rtlCol="0" anchor="ctr"/>
-          <a:lstStyle/>
-          <a:p>
-            <a:endParaRPr lang="en-US"/>
-          </a:p>
-        </p:txBody>
-      </p:sp>
-      <p:sp>
-        <p:nvSpPr>
-          <p:cNvPr id="5" name="Notes Placeholder 4"/>
-          <p:cNvSpPr>
-            <a:spLocks noGrp="1"/>
-          </p:cNvSpPr>
-          <p:nvPr>
-            <p:ph type="body" sz="quarter" idx="3"/>
-          </p:nvPr>
-        </p:nvSpPr>
-        <p:spPr>
-          <a:xfrm>
-            <a:off x="685800" y="4400550"/>
-            <a:ext cx="5486400" cy="3600450"/>
-          </a:xfrm>
-          <a:prstGeom prst="rect">
-            <a:avLst/>
-          </a:prstGeom>
-        </p:spPr>
-        <p:txBody>
-          <a:bodyPr vert="horz" lIns="91440" tIns="45720" rIns="91440" bIns="45720" rtlCol="0"/>
-          <a:lstStyle/>
-          <a:p>
-            <a:pPr lvl="0"/>
-            <a:r>
-              <a:rPr lang="en-US"/>
-              <a:t>Click to edit Master text styles</a:t>
-            </a:r>
-          </a:p>
-          <a:p>
-            <a:pPr lvl="1"/>
-            <a:r>
-              <a:rPr lang="en-US"/>
-              <a:t>Second level</a:t>
-            </a:r>
-          </a:p>
-          <a:p>
-            <a:pPr lvl="2"/>
-            <a:r>
-              <a:rPr lang="en-US"/>
-              <a:t>Third level</a:t>
-            </a:r>
-          </a:p>
-          <a:p>
-            <a:pPr lvl="3"/>
-            <a:r>
-              <a:rPr lang="en-US"/>
-              <a:t>Fourth level</a:t>
-            </a:r>
-          </a:p>
-          <a:p>
-            <a:pPr lvl="4"/>
-            <a:r>
-              <a:rPr lang="en-US"/>
-              <a:t>Fifth level</a:t>
-            </a:r>
-          </a:p>
-        </p:txBody>
-      </p:sp>
-      <p:sp>
-        <p:nvSpPr>
-          <p:cNvPr id="6" name="Footer Placeholder 5"/>
-          <p:cNvSpPr>
-            <a:spLocks noGrp="1"/>
-          </p:cNvSpPr>
-          <p:nvPr>
-            <p:ph type="ftr" sz="quarter" idx="4"/>
-          </p:nvPr>
-        </p:nvSpPr>
-        <p:spPr>
-          <a:xfrm>
-            <a:off x="0" y="8685213"/>
-            <a:ext cx="2971800" cy="458787"/>
-          </a:xfrm>
-          <a:prstGeom prst="rect">
-            <a:avLst/>
-          </a:prstGeom>
-        </p:spPr>
-        <p:txBody>
-          <a:bodyPr vert="horz" lIns="91440" tIns="45720" rIns="91440" bIns="45720" rtlCol="0" anchor="b"/>
-          <a:lstStyle>
-            <a:lvl1pPr algn="l">
-              <a:defRPr sz="1200"/>
-            </a:lvl1pPr>
-          </a:lstStyle>
-          <a:p>
-            <a:endParaRPr lang="en-US"/>
-          </a:p>
-        </p:txBody>
-      </p:sp>
-      <p:sp>
-        <p:nvSpPr>
-          <p:cNvPr id="7" name="Slide Number Placeholder 6"/>
-          <p:cNvSpPr>
-            <a:spLocks noGrp="1"/>
-          </p:cNvSpPr>
-          <p:nvPr>
-            <p:ph type="sldNum" sz="quarter" idx="5"/>
-          </p:nvPr>
-        </p:nvSpPr>
-        <p:spPr>
-          <a:xfrm>
-            <a:off x="3884613" y="8685213"/>
-            <a:ext cx="2971800" cy="458787"/>
-          </a:xfrm>
-          <a:prstGeom prst="rect">
-            <a:avLst/>
-          </a:prstGeom>
-        </p:spPr>
-        <p:txBody>
-          <a:bodyPr vert="horz" lIns="91440" tIns="45720" rIns="91440" bIns="45720" rtlCol="0" anchor="b"/>
-          <a:lstStyle>
-            <a:lvl1pPr algn="r">
-              <a:defRPr sz="1200"/>
-            </a:lvl1pPr>
-          </a:lstStyle>
-          <a:p>
-            <a:fld id="{CE5E9CC1-C706-0F49-92D6-E571CC5EEA8F}" type="slidenum">
-              <a:rPr lang="en-US"/>
-              <a:t>‹#›</a:t>
-            </a:fld>
-            <a:endParaRPr lang="en-US"/>
-          </a:p>
-        </p:txBody>
-      </p:sp>
     </p:spTree>
     <p:extLst>
       <p:ext uri="{BB962C8B-B14F-4D97-AF65-F5344CB8AC3E}">
-        <p14:creationId xmlns:p14="http://schemas.microsoft.com/office/powerpoint/2010/main" val="1024086991"/>
+        <p14:creationId xmlns:p14="http://schemas.microsoft.com/office/powerpoint/2010/main" val="2580907066"/>
       </p:ext>
     </p:extLst>
   </p:cSld>
@@ -1102,7 +966,6 @@
               <a:rPr lang="en-US" dirty="0"/>
               <a:t>SentinelRisk is a real-time AI/NLP financial risk engine. It ingests unstructured text, scores sentiment and impact, and tactically rebalances an index to improve risk-adjusted returns. Headline numbers: 7.69% vs 6.50% equal-weight, Sharpe 2.16, max drawdown -8.69%.</a:t>
             </a:r>
-            <a:endParaRPr lang="en-US" dirty="0"/>
           </a:p>
         </p:txBody>
       </p:sp>
@@ -1190,7 +1053,6 @@
               <a:rPr lang="en-US" dirty="0"/>
               <a:t>Markets react instantly to unstructured text. SentinelRisk quantifies that impact and tilts index weights tactically, avoiding drawdowns from negative sentiment while keeping upside.</a:t>
             </a:r>
-            <a:endParaRPr lang="en-US" dirty="0"/>
           </a:p>
         </p:txBody>
       </p:sp>
@@ -1278,7 +1140,6 @@
               <a:rPr lang="en-US" dirty="0"/>
               <a:t>Modular pipeline: ingest news and tweets into a common schema, extract entities, score sentiment with FinBERT, classify events, aggregate to a 1-10 impact score, drive Module A's rebalancing, and visualise in Streamlit.</a:t>
             </a:r>
-            <a:endParaRPr lang="en-US" dirty="0"/>
           </a:p>
         </p:txBody>
       </p:sp>
@@ -1366,7 +1227,6 @@
               <a:rPr lang="en-US" dirty="0"/>
               <a:t>FinBERT for sentiment, hybrid rules plus zero-shot DeBERTa for events. Impact score = 10 x (0.4*|sentiment| + 0.35*event weight + 0.25*severity keywords), rounded and clipped.</a:t>
             </a:r>
-            <a:endParaRPr lang="en-US" dirty="0"/>
           </a:p>
         </p:txBody>
       </p:sp>
@@ -1454,7 +1314,6 @@
               <a:rPr lang="en-US" dirty="0"/>
               <a:t>Module A tilts a base equal-weight portfolio using an EWMA of sentiment, an exponential tilt, and iterative water-filling to enforce 2 to 15 percent bounds. Weights from T-1 signals apply to T returns. Transaction costs of 5 bps are charged.</a:t>
             </a:r>
-            <a:endParaRPr lang="en-US" dirty="0"/>
           </a:p>
         </p:txBody>
       </p:sp>
@@ -1542,7 +1401,6 @@
               <a:rPr lang="en-US" dirty="0"/>
               <a:t>Replay-window backtest, strict chronological separation (T-1 signals on T returns), 5 bps costs. Dynamic: 7.69% vs 6.50% equal-weight, Sharpe 2.16, vol 14.69%, max drawdown -8.69%, average turnover 1.37%.</a:t>
             </a:r>
-            <a:endParaRPr lang="en-US" dirty="0"/>
           </a:p>
         </p:txBody>
       </p:sp>
@@ -1630,7 +1488,6 @@
               <a:rPr lang="en-US" dirty="0"/>
               <a:t>Latency solved with batching; entity ambiguity with multi-ticker matching and MARKET fallback; noise with the hybrid classifier; reliability with graceful offline fallbacks; look-ahead bias with strict chronological backtesting.</a:t>
             </a:r>
-            <a:endParaRPr lang="en-US" dirty="0"/>
           </a:p>
         </p:txBody>
       </p:sp>
@@ -1718,7 +1575,6 @@
               <a:rPr lang="en-US" dirty="0"/>
               <a:t>Next: Module B stress testing, GDELT for macro news, Kafka streaming, fine-tuned FinBERT, and convex optimisation constraints.</a:t>
             </a:r>
-            <a:endParaRPr lang="en-US" dirty="0"/>
           </a:p>
         </p:txBody>
       </p:sp>
@@ -1806,7 +1662,6 @@
               <a:rPr lang="en-US" dirty="0"/>
               <a:t>Close: SentinelRisk converts unstructured text into disciplined, cost-aware, bounded portfolio tilts with strict no-look-ahead evaluation.</a:t>
             </a:r>
-            <a:endParaRPr lang="en-US" dirty="0"/>
           </a:p>
         </p:txBody>
       </p:sp>
@@ -1879,6 +1734,11 @@
 <file path=ppt/slideMasters/slideMaster1.xml><?xml version="1.0" encoding="utf-8"?>
 <p:sldMaster xmlns:a="http://schemas.openxmlformats.org/drawingml/2006/main" xmlns:r="http://schemas.openxmlformats.org/officeDocument/2006/relationships" xmlns:p="http://schemas.openxmlformats.org/presentationml/2006/main">
   <p:cSld>
+    <p:bg>
+      <p:bgRef idx="1001">
+        <a:schemeClr val="bg1"/>
+      </p:bgRef>
+    </p:bg>
     <p:spTree>
       <p:nvGrpSpPr>
         <p:cNvPr id="1" name=""/>
@@ -2161,6 +2021,7 @@
         <a:solidFill>
           <a:srgbClr val="0A1628"/>
         </a:solidFill>
+        <a:effectLst/>
       </p:bgPr>
     </p:bg>
     <p:spTree>
@@ -2219,7 +2080,7 @@
           <a:lstStyle/>
           <a:p>
             <a:pPr algn="ctr">
-              <a:defRPr b="1" sz="1000">
+              <a:defRPr sz="1000" b="1">
                 <a:solidFill>
                   <a:srgbClr val="FFFFFF"/>
                 </a:solidFill>
@@ -2254,26 +2115,31 @@
           <a:lstStyle/>
           <a:p>
             <a:pPr>
-              <a:defRPr b="1" sz="2800">
+              <a:defRPr sz="2800" b="1">
                 <a:solidFill>
                   <a:srgbClr val="FFFFFF"/>
                 </a:solidFill>
               </a:defRPr>
             </a:pPr>
             <a:r>
+              <a:rPr dirty="0"/>
               <a:t>AI/NLP Financial Risk Engine &amp;</a:t>
             </a:r>
-            <a:br/>
+            <a:br>
+              <a:rPr dirty="0"/>
+            </a:br>
+            <a:endParaRPr lang="en-IN" dirty="0"/>
           </a:p>
           <a:p>
             <a:pPr>
-              <a:defRPr b="1" sz="2800">
+              <a:defRPr sz="2800" b="1">
                 <a:solidFill>
                   <a:srgbClr val="00C8C8"/>
                 </a:solidFill>
               </a:defRPr>
             </a:pPr>
             <a:r>
+              <a:rPr lang="en-IN" dirty="0"/>
               <a:t>Tactical Index Rebalancing</a:t>
             </a:r>
           </a:p>
@@ -2287,7 +2153,7 @@
         </p:nvSpPr>
         <p:spPr>
           <a:xfrm>
-            <a:off x="457200" y="2011680"/>
+            <a:off x="365760" y="2423160"/>
             <a:ext cx="8229600" cy="457200"/>
           </a:xfrm>
           <a:prstGeom prst="rect">
@@ -2354,6 +2220,7 @@
           <a:lstStyle/>
           <a:p>
             <a:pPr algn="ctr"/>
+            <a:endParaRPr/>
           </a:p>
         </p:txBody>
       </p:sp>
@@ -2380,7 +2247,7 @@
           <a:lstStyle/>
           <a:p>
             <a:pPr>
-              <a:defRPr b="1" sz="1100">
+              <a:defRPr sz="1100" b="1">
                 <a:solidFill>
                   <a:srgbClr val="00C8C8"/>
                 </a:solidFill>
@@ -2712,6 +2579,7 @@
           <a:lstStyle/>
           <a:p>
             <a:pPr algn="ctr"/>
+            <a:endParaRPr/>
           </a:p>
         </p:txBody>
       </p:sp>
@@ -2738,7 +2606,7 @@
           <a:lstStyle/>
           <a:p>
             <a:pPr>
-              <a:defRPr b="1" sz="1100">
+              <a:defRPr sz="1100" b="1">
                 <a:solidFill>
                   <a:srgbClr val="00C8C8"/>
                 </a:solidFill>
@@ -2906,6 +2774,7 @@
         <a:solidFill>
           <a:srgbClr val="FFFFFF"/>
         </a:solidFill>
+        <a:effectLst/>
       </p:bgPr>
     </p:bg>
     <p:spTree>
@@ -2943,7 +2812,7 @@
           <a:bodyPr wrap="square" lIns="0" tIns="0" rIns="0" bIns="0" rtlCol="0" anchor="ctr"/>
           <a:lstStyle/>
           <a:p>
-            <a:pPr indent="0" marL="0">
+            <a:pPr marL="0" indent="0">
               <a:buNone/>
             </a:pPr>
             <a:r>
@@ -3005,295 +2874,7 @@
       </p:sp>
       <p:pic>
         <p:nvPicPr>
-          <p:cNvPr id="5" name="Image 0" descr="preencoded.png">    </p:cNvPr>
-          <p:cNvPicPr>
-            <a:picLocks noChangeAspect="1"/>
-          </p:cNvPicPr>
-          <p:nvPr/>
-        </p:nvPicPr>
-        <p:blipFill>
-          <a:blip r:embed="rId1"/>
-          <a:stretch>
-            <a:fillRect/>
-          </a:stretch>
-        </p:blipFill>
-        <p:spPr>
-          <a:xfrm>
-            <a:off x="886968" y="1709928"/>
-            <a:ext cx="420624" cy="420624"/>
-          </a:xfrm>
-          <a:prstGeom prst="rect">
-            <a:avLst/>
-          </a:prstGeom>
-        </p:spPr>
-      </p:pic>
-      <p:sp>
-        <p:nvSpPr>
-          <p:cNvPr id="6" name="Text 3"/>
-          <p:cNvSpPr txBox="1"/>
-          <p:nvPr/>
-        </p:nvSpPr>
-        <p:spPr>
-          <a:xfrm>
-            <a:off x="731520" y="2468880"/>
-            <a:ext cx="2194560" cy="365760"/>
-          </a:xfrm>
-          <a:prstGeom prst="rect">
-            <a:avLst/>
-          </a:prstGeom>
-          <a:noFill/>
-          <a:ln/>
-        </p:spPr>
-        <p:txBody>
-          <a:bodyPr wrap="square" lIns="0" tIns="0" rIns="0" bIns="0" rtlCol="0" anchor="ctr"/>
-          <a:lstStyle/>
-          <a:p>
-            <a:pPr indent="0" marL="0">
-              <a:buNone/>
-            </a:pPr>
-            <a:r>
-              <a:rPr lang="en-US" sz="2200" b="1" dirty="0">
-                <a:solidFill>
-                  <a:srgbClr val="0A1628"/>
-                </a:solidFill>
-                <a:latin typeface="Cambria" pitchFamily="34" charset="0"/>
-                <a:ea typeface="Cambria" pitchFamily="34" charset="-122"/>
-                <a:cs typeface="Cambria" pitchFamily="34" charset="-120"/>
-              </a:rPr>
-              <a:t>The Problem</a:t>
-            </a:r>
-            <a:endParaRPr lang="en-US" sz="2200" dirty="0"/>
-          </a:p>
-        </p:txBody>
-      </p:sp>
-      <p:sp>
-        <p:nvSpPr>
-          <p:cNvPr id="7" name="Text 4"/>
-          <p:cNvSpPr txBox="1"/>
-          <p:nvPr/>
-        </p:nvSpPr>
-        <p:spPr>
-          <a:xfrm>
-            <a:off x="731520" y="2880360"/>
-            <a:ext cx="2194560" cy="1371600"/>
-          </a:xfrm>
-          <a:prstGeom prst="rect">
-            <a:avLst/>
-          </a:prstGeom>
-          <a:noFill/>
-          <a:ln/>
-        </p:spPr>
-        <p:txBody>
-          <a:bodyPr wrap="square" lIns="0" tIns="0" rIns="0" bIns="0" rtlCol="0" anchor="t"/>
-          <a:lstStyle/>
-          <a:p>
-            <a:pPr indent="0" marL="0">
-              <a:buNone/>
-            </a:pPr>
-            <a:r>
-              <a:rPr lang="en-US" sz="1400" dirty="0">
-                <a:solidFill>
-                  <a:srgbClr val="475569"/>
-                </a:solidFill>
-                <a:latin typeface="Calibri" pitchFamily="34" charset="0"/>
-                <a:ea typeface="Calibri" pitchFamily="34" charset="-122"/>
-                <a:cs typeface="Calibri" pitchFamily="34" charset="-120"/>
-              </a:rPr>
-              <a:t>Prices react in seconds to unstructured text: news headlines and social media. Static index weights can't.</a:t>
-            </a:r>
-            <a:endParaRPr lang="en-US" sz="1400" dirty="0"/>
-          </a:p>
-        </p:txBody>
-      </p:sp>
-      <p:sp>
-        <p:nvSpPr>
-          <p:cNvPr id="8" name="Shape 5"/>
-          <p:cNvSpPr/>
-          <p:nvPr/>
-        </p:nvSpPr>
-        <p:spPr>
-          <a:xfrm>
-            <a:off x="3291840" y="1280160"/>
-            <a:ext cx="2651760" cy="3108960"/>
-          </a:xfrm>
-          <a:prstGeom prst="roundRect">
-            <a:avLst>
-              <a:gd name="adj" fmla="val 3448"/>
-            </a:avLst>
-          </a:prstGeom>
-          <a:solidFill>
-            <a:srgbClr val="F1F5F9"/>
-          </a:solidFill>
-          <a:ln/>
-        </p:spPr>
-      </p:sp>
-      <p:sp>
-        <p:nvSpPr>
-          <p:cNvPr id="9" name="Shape 6"/>
-          <p:cNvSpPr/>
-          <p:nvPr/>
-        </p:nvSpPr>
-        <p:spPr>
-          <a:xfrm>
-            <a:off x="3566160" y="1554480"/>
-            <a:ext cx="731520" cy="731520"/>
-          </a:xfrm>
-          <a:prstGeom prst="ellipse">
-            <a:avLst/>
-          </a:prstGeom>
-          <a:solidFill>
-            <a:srgbClr val="0A1628"/>
-          </a:solidFill>
-          <a:ln/>
-        </p:spPr>
-      </p:sp>
-      <p:pic>
-        <p:nvPicPr>
-          <p:cNvPr id="10" name="Image 1" descr="preencoded.png">    </p:cNvPr>
-          <p:cNvPicPr>
-            <a:picLocks noChangeAspect="1"/>
-          </p:cNvPicPr>
-          <p:nvPr/>
-        </p:nvPicPr>
-        <p:blipFill>
-          <a:blip r:embed="rId2"/>
-          <a:stretch>
-            <a:fillRect/>
-          </a:stretch>
-        </p:blipFill>
-        <p:spPr>
-          <a:xfrm>
-            <a:off x="3721608" y="1709928"/>
-            <a:ext cx="420624" cy="420624"/>
-          </a:xfrm>
-          <a:prstGeom prst="rect">
-            <a:avLst/>
-          </a:prstGeom>
-        </p:spPr>
-      </p:pic>
-      <p:sp>
-        <p:nvSpPr>
-          <p:cNvPr id="11" name="Text 7"/>
-          <p:cNvSpPr txBox="1"/>
-          <p:nvPr/>
-        </p:nvSpPr>
-        <p:spPr>
-          <a:xfrm>
-            <a:off x="3566160" y="2468880"/>
-            <a:ext cx="2194560" cy="365760"/>
-          </a:xfrm>
-          <a:prstGeom prst="rect">
-            <a:avLst/>
-          </a:prstGeom>
-          <a:noFill/>
-          <a:ln/>
-        </p:spPr>
-        <p:txBody>
-          <a:bodyPr wrap="square" lIns="0" tIns="0" rIns="0" bIns="0" rtlCol="0" anchor="ctr"/>
-          <a:lstStyle/>
-          <a:p>
-            <a:pPr indent="0" marL="0">
-              <a:buNone/>
-            </a:pPr>
-            <a:r>
-              <a:rPr lang="en-US" sz="2200" b="1" dirty="0">
-                <a:solidFill>
-                  <a:srgbClr val="0A1628"/>
-                </a:solidFill>
-                <a:latin typeface="Cambria" pitchFamily="34" charset="0"/>
-                <a:ea typeface="Cambria" pitchFamily="34" charset="-122"/>
-                <a:cs typeface="Cambria" pitchFamily="34" charset="-120"/>
-              </a:rPr>
-              <a:t>The Solution</a:t>
-            </a:r>
-            <a:endParaRPr lang="en-US" sz="2200" dirty="0"/>
-          </a:p>
-        </p:txBody>
-      </p:sp>
-      <p:sp>
-        <p:nvSpPr>
-          <p:cNvPr id="12" name="Text 8"/>
-          <p:cNvSpPr txBox="1"/>
-          <p:nvPr/>
-        </p:nvSpPr>
-        <p:spPr>
-          <a:xfrm>
-            <a:off x="3566160" y="2880360"/>
-            <a:ext cx="2194560" cy="1371600"/>
-          </a:xfrm>
-          <a:prstGeom prst="rect">
-            <a:avLst/>
-          </a:prstGeom>
-          <a:noFill/>
-          <a:ln/>
-        </p:spPr>
-        <p:txBody>
-          <a:bodyPr wrap="square" lIns="0" tIns="0" rIns="0" bIns="0" rtlCol="0" anchor="t"/>
-          <a:lstStyle/>
-          <a:p>
-            <a:pPr indent="0" marL="0">
-              <a:buNone/>
-            </a:pPr>
-            <a:r>
-              <a:rPr lang="en-US" sz="1400" dirty="0">
-                <a:solidFill>
-                  <a:srgbClr val="475569"/>
-                </a:solidFill>
-                <a:latin typeface="Calibri" pitchFamily="34" charset="0"/>
-                <a:ea typeface="Calibri" pitchFamily="34" charset="-122"/>
-                <a:cs typeface="Calibri" pitchFamily="34" charset="-120"/>
-              </a:rPr>
-              <a:t>SentinelRisk quantifies textual impact in real time and tactically tilts index weights.</a:t>
-            </a:r>
-            <a:endParaRPr lang="en-US" sz="1400" dirty="0"/>
-          </a:p>
-        </p:txBody>
-      </p:sp>
-      <p:sp>
-        <p:nvSpPr>
-          <p:cNvPr id="13" name="Shape 9"/>
-          <p:cNvSpPr/>
-          <p:nvPr/>
-        </p:nvSpPr>
-        <p:spPr>
-          <a:xfrm>
-            <a:off x="6126480" y="1280160"/>
-            <a:ext cx="2651760" cy="3108960"/>
-          </a:xfrm>
-          <a:prstGeom prst="roundRect">
-            <a:avLst>
-              <a:gd name="adj" fmla="val 3448"/>
-            </a:avLst>
-          </a:prstGeom>
-          <a:solidFill>
-            <a:srgbClr val="F1F5F9"/>
-          </a:solidFill>
-          <a:ln/>
-        </p:spPr>
-      </p:sp>
-      <p:sp>
-        <p:nvSpPr>
-          <p:cNvPr id="14" name="Shape 10"/>
-          <p:cNvSpPr/>
-          <p:nvPr/>
-        </p:nvSpPr>
-        <p:spPr>
-          <a:xfrm>
-            <a:off x="6400800" y="1554480"/>
-            <a:ext cx="731520" cy="731520"/>
-          </a:xfrm>
-          <a:prstGeom prst="ellipse">
-            <a:avLst/>
-          </a:prstGeom>
-          <a:solidFill>
-            <a:srgbClr val="0A1628"/>
-          </a:solidFill>
-          <a:ln/>
-        </p:spPr>
-      </p:sp>
-      <p:pic>
-        <p:nvPicPr>
-          <p:cNvPr id="15" name="Image 2" descr="preencoded.png">    </p:cNvPr>
+          <p:cNvPr id="5" name="Image 0" descr="preencoded.png"/>
           <p:cNvPicPr>
             <a:picLocks noChangeAspect="1"/>
           </p:cNvPicPr>
@@ -3307,7 +2888,7 @@
         </p:blipFill>
         <p:spPr>
           <a:xfrm>
-            <a:off x="6556248" y="1709928"/>
+            <a:off x="886968" y="1709928"/>
             <a:ext cx="420624" cy="420624"/>
           </a:xfrm>
           <a:prstGeom prst="rect">
@@ -3317,13 +2898,13 @@
       </p:pic>
       <p:sp>
         <p:nvSpPr>
-          <p:cNvPr id="16" name="Text 11"/>
-          <p:cNvSpPr txBox="1"/>
-          <p:nvPr/>
-        </p:nvSpPr>
-        <p:spPr>
-          <a:xfrm>
-            <a:off x="6400800" y="2468880"/>
+          <p:cNvPr id="6" name="Text 3"/>
+          <p:cNvSpPr txBox="1"/>
+          <p:nvPr/>
+        </p:nvSpPr>
+        <p:spPr>
+          <a:xfrm>
+            <a:off x="731520" y="2468880"/>
             <a:ext cx="2194560" cy="365760"/>
           </a:xfrm>
           <a:prstGeom prst="rect">
@@ -3336,7 +2917,7 @@
           <a:bodyPr wrap="square" lIns="0" tIns="0" rIns="0" bIns="0" rtlCol="0" anchor="ctr"/>
           <a:lstStyle/>
           <a:p>
-            <a:pPr indent="0" marL="0">
+            <a:pPr marL="0" indent="0">
               <a:buNone/>
             </a:pPr>
             <a:r>
@@ -3348,7 +2929,7 @@
                 <a:ea typeface="Cambria" pitchFamily="34" charset="-122"/>
                 <a:cs typeface="Cambria" pitchFamily="34" charset="-120"/>
               </a:rPr>
-              <a:t>The Edge</a:t>
+              <a:t>The Problem</a:t>
             </a:r>
             <a:endParaRPr lang="en-US" sz="2200" dirty="0"/>
           </a:p>
@@ -3356,13 +2937,13 @@
       </p:sp>
       <p:sp>
         <p:nvSpPr>
-          <p:cNvPr id="17" name="Text 12"/>
-          <p:cNvSpPr txBox="1"/>
-          <p:nvPr/>
-        </p:nvSpPr>
-        <p:spPr>
-          <a:xfrm>
-            <a:off x="6400800" y="2880360"/>
+          <p:cNvPr id="7" name="Text 4"/>
+          <p:cNvSpPr txBox="1"/>
+          <p:nvPr/>
+        </p:nvSpPr>
+        <p:spPr>
+          <a:xfrm>
+            <a:off x="731520" y="2880360"/>
             <a:ext cx="2194560" cy="1371600"/>
           </a:xfrm>
           <a:prstGeom prst="rect">
@@ -3375,7 +2956,7 @@
           <a:bodyPr wrap="square" lIns="0" tIns="0" rIns="0" bIns="0" rtlCol="0" anchor="t"/>
           <a:lstStyle/>
           <a:p>
-            <a:pPr indent="0" marL="0">
+            <a:pPr marL="0" indent="0">
               <a:buNone/>
             </a:pPr>
             <a:r>
@@ -3387,7 +2968,7 @@
                 <a:ea typeface="Calibri" pitchFamily="34" charset="-122"/>
                 <a:cs typeface="Calibri" pitchFamily="34" charset="-120"/>
               </a:rPr>
-              <a:t>Cuts exposure to negative-sentiment drawdowns while still capturing upside.</a:t>
+              <a:t>Prices react in seconds to unstructured text: news headlines and social media. Static index weights can't.</a:t>
             </a:r>
             <a:endParaRPr lang="en-US" sz="1400" dirty="0"/>
           </a:p>
@@ -3395,14 +2976,80 @@
       </p:sp>
       <p:sp>
         <p:nvSpPr>
-          <p:cNvPr id="18" name="Text 13"/>
-          <p:cNvSpPr txBox="1"/>
-          <p:nvPr/>
-        </p:nvSpPr>
-        <p:spPr>
-          <a:xfrm>
-            <a:off x="457200" y="4754880"/>
-            <a:ext cx="2743200" cy="228600"/>
+          <p:cNvPr id="8" name="Shape 5"/>
+          <p:cNvSpPr/>
+          <p:nvPr/>
+        </p:nvSpPr>
+        <p:spPr>
+          <a:xfrm>
+            <a:off x="3291840" y="1280160"/>
+            <a:ext cx="2651760" cy="3108960"/>
+          </a:xfrm>
+          <a:prstGeom prst="roundRect">
+            <a:avLst>
+              <a:gd name="adj" fmla="val 3448"/>
+            </a:avLst>
+          </a:prstGeom>
+          <a:solidFill>
+            <a:srgbClr val="F1F5F9"/>
+          </a:solidFill>
+          <a:ln/>
+        </p:spPr>
+      </p:sp>
+      <p:sp>
+        <p:nvSpPr>
+          <p:cNvPr id="9" name="Shape 6"/>
+          <p:cNvSpPr/>
+          <p:nvPr/>
+        </p:nvSpPr>
+        <p:spPr>
+          <a:xfrm>
+            <a:off x="3566160" y="1554480"/>
+            <a:ext cx="731520" cy="731520"/>
+          </a:xfrm>
+          <a:prstGeom prst="ellipse">
+            <a:avLst/>
+          </a:prstGeom>
+          <a:solidFill>
+            <a:srgbClr val="0A1628"/>
+          </a:solidFill>
+          <a:ln/>
+        </p:spPr>
+      </p:sp>
+      <p:pic>
+        <p:nvPicPr>
+          <p:cNvPr id="10" name="Image 1" descr="preencoded.png"/>
+          <p:cNvPicPr>
+            <a:picLocks noChangeAspect="1"/>
+          </p:cNvPicPr>
+          <p:nvPr/>
+        </p:nvPicPr>
+        <p:blipFill>
+          <a:blip r:embed="rId4"/>
+          <a:stretch>
+            <a:fillRect/>
+          </a:stretch>
+        </p:blipFill>
+        <p:spPr>
+          <a:xfrm>
+            <a:off x="3721608" y="1709928"/>
+            <a:ext cx="420624" cy="420624"/>
+          </a:xfrm>
+          <a:prstGeom prst="rect">
+            <a:avLst/>
+          </a:prstGeom>
+        </p:spPr>
+      </p:pic>
+      <p:sp>
+        <p:nvSpPr>
+          <p:cNvPr id="11" name="Text 7"/>
+          <p:cNvSpPr txBox="1"/>
+          <p:nvPr/>
+        </p:nvSpPr>
+        <p:spPr>
+          <a:xfrm>
+            <a:off x="3566160" y="2468880"/>
+            <a:ext cx="2194560" cy="365760"/>
           </a:xfrm>
           <a:prstGeom prst="rect">
             <a:avLst/>
@@ -3414,11 +3061,50 @@
           <a:bodyPr wrap="square" lIns="0" tIns="0" rIns="0" bIns="0" rtlCol="0" anchor="ctr"/>
           <a:lstStyle/>
           <a:p>
-            <a:pPr indent="0" marL="0">
-              <a:buNone/>
-            </a:pPr>
-            <a:r>
-              <a:rPr lang="en-US" sz="1000" dirty="0">
+            <a:pPr marL="0" indent="0">
+              <a:buNone/>
+            </a:pPr>
+            <a:r>
+              <a:rPr lang="en-US" sz="2200" b="1" dirty="0">
+                <a:solidFill>
+                  <a:srgbClr val="0A1628"/>
+                </a:solidFill>
+                <a:latin typeface="Cambria" pitchFamily="34" charset="0"/>
+                <a:ea typeface="Cambria" pitchFamily="34" charset="-122"/>
+                <a:cs typeface="Cambria" pitchFamily="34" charset="-120"/>
+              </a:rPr>
+              <a:t>The Solution</a:t>
+            </a:r>
+            <a:endParaRPr lang="en-US" sz="2200" dirty="0"/>
+          </a:p>
+        </p:txBody>
+      </p:sp>
+      <p:sp>
+        <p:nvSpPr>
+          <p:cNvPr id="12" name="Text 8"/>
+          <p:cNvSpPr txBox="1"/>
+          <p:nvPr/>
+        </p:nvSpPr>
+        <p:spPr>
+          <a:xfrm>
+            <a:off x="3566160" y="2880360"/>
+            <a:ext cx="2194560" cy="1371600"/>
+          </a:xfrm>
+          <a:prstGeom prst="rect">
+            <a:avLst/>
+          </a:prstGeom>
+          <a:noFill/>
+          <a:ln/>
+        </p:spPr>
+        <p:txBody>
+          <a:bodyPr wrap="square" lIns="0" tIns="0" rIns="0" bIns="0" rtlCol="0" anchor="t"/>
+          <a:lstStyle/>
+          <a:p>
+            <a:pPr marL="0" indent="0">
+              <a:buNone/>
+            </a:pPr>
+            <a:r>
+              <a:rPr lang="en-US" sz="1400" dirty="0">
                 <a:solidFill>
                   <a:srgbClr val="475569"/>
                 </a:solidFill>
@@ -3426,6 +3112,189 @@
                 <a:ea typeface="Calibri" pitchFamily="34" charset="-122"/>
                 <a:cs typeface="Calibri" pitchFamily="34" charset="-120"/>
               </a:rPr>
+              <a:t>SentinelRisk quantifies textual impact in real time and tactically tilts index weights.</a:t>
+            </a:r>
+            <a:endParaRPr lang="en-US" sz="1400" dirty="0"/>
+          </a:p>
+        </p:txBody>
+      </p:sp>
+      <p:sp>
+        <p:nvSpPr>
+          <p:cNvPr id="13" name="Shape 9"/>
+          <p:cNvSpPr/>
+          <p:nvPr/>
+        </p:nvSpPr>
+        <p:spPr>
+          <a:xfrm>
+            <a:off x="6126480" y="1280160"/>
+            <a:ext cx="2651760" cy="3108960"/>
+          </a:xfrm>
+          <a:prstGeom prst="roundRect">
+            <a:avLst>
+              <a:gd name="adj" fmla="val 3448"/>
+            </a:avLst>
+          </a:prstGeom>
+          <a:solidFill>
+            <a:srgbClr val="F1F5F9"/>
+          </a:solidFill>
+          <a:ln/>
+        </p:spPr>
+      </p:sp>
+      <p:sp>
+        <p:nvSpPr>
+          <p:cNvPr id="14" name="Shape 10"/>
+          <p:cNvSpPr/>
+          <p:nvPr/>
+        </p:nvSpPr>
+        <p:spPr>
+          <a:xfrm>
+            <a:off x="6400800" y="1554480"/>
+            <a:ext cx="731520" cy="731520"/>
+          </a:xfrm>
+          <a:prstGeom prst="ellipse">
+            <a:avLst/>
+          </a:prstGeom>
+          <a:solidFill>
+            <a:srgbClr val="0A1628"/>
+          </a:solidFill>
+          <a:ln/>
+        </p:spPr>
+      </p:sp>
+      <p:pic>
+        <p:nvPicPr>
+          <p:cNvPr id="15" name="Image 2" descr="preencoded.png"/>
+          <p:cNvPicPr>
+            <a:picLocks noChangeAspect="1"/>
+          </p:cNvPicPr>
+          <p:nvPr/>
+        </p:nvPicPr>
+        <p:blipFill>
+          <a:blip r:embed="rId5"/>
+          <a:stretch>
+            <a:fillRect/>
+          </a:stretch>
+        </p:blipFill>
+        <p:spPr>
+          <a:xfrm>
+            <a:off x="6556248" y="1709928"/>
+            <a:ext cx="420624" cy="420624"/>
+          </a:xfrm>
+          <a:prstGeom prst="rect">
+            <a:avLst/>
+          </a:prstGeom>
+        </p:spPr>
+      </p:pic>
+      <p:sp>
+        <p:nvSpPr>
+          <p:cNvPr id="16" name="Text 11"/>
+          <p:cNvSpPr txBox="1"/>
+          <p:nvPr/>
+        </p:nvSpPr>
+        <p:spPr>
+          <a:xfrm>
+            <a:off x="6400800" y="2468880"/>
+            <a:ext cx="2194560" cy="365760"/>
+          </a:xfrm>
+          <a:prstGeom prst="rect">
+            <a:avLst/>
+          </a:prstGeom>
+          <a:noFill/>
+          <a:ln/>
+        </p:spPr>
+        <p:txBody>
+          <a:bodyPr wrap="square" lIns="0" tIns="0" rIns="0" bIns="0" rtlCol="0" anchor="ctr"/>
+          <a:lstStyle/>
+          <a:p>
+            <a:pPr marL="0" indent="0">
+              <a:buNone/>
+            </a:pPr>
+            <a:r>
+              <a:rPr lang="en-US" sz="2200" b="1" dirty="0">
+                <a:solidFill>
+                  <a:srgbClr val="0A1628"/>
+                </a:solidFill>
+                <a:latin typeface="Cambria" pitchFamily="34" charset="0"/>
+                <a:ea typeface="Cambria" pitchFamily="34" charset="-122"/>
+                <a:cs typeface="Cambria" pitchFamily="34" charset="-120"/>
+              </a:rPr>
+              <a:t>The Edge</a:t>
+            </a:r>
+            <a:endParaRPr lang="en-US" sz="2200" dirty="0"/>
+          </a:p>
+        </p:txBody>
+      </p:sp>
+      <p:sp>
+        <p:nvSpPr>
+          <p:cNvPr id="17" name="Text 12"/>
+          <p:cNvSpPr txBox="1"/>
+          <p:nvPr/>
+        </p:nvSpPr>
+        <p:spPr>
+          <a:xfrm>
+            <a:off x="6400800" y="2880360"/>
+            <a:ext cx="2194560" cy="1371600"/>
+          </a:xfrm>
+          <a:prstGeom prst="rect">
+            <a:avLst/>
+          </a:prstGeom>
+          <a:noFill/>
+          <a:ln/>
+        </p:spPr>
+        <p:txBody>
+          <a:bodyPr wrap="square" lIns="0" tIns="0" rIns="0" bIns="0" rtlCol="0" anchor="t"/>
+          <a:lstStyle/>
+          <a:p>
+            <a:pPr marL="0" indent="0">
+              <a:buNone/>
+            </a:pPr>
+            <a:r>
+              <a:rPr lang="en-US" sz="1400" dirty="0">
+                <a:solidFill>
+                  <a:srgbClr val="475569"/>
+                </a:solidFill>
+                <a:latin typeface="Calibri" pitchFamily="34" charset="0"/>
+                <a:ea typeface="Calibri" pitchFamily="34" charset="-122"/>
+                <a:cs typeface="Calibri" pitchFamily="34" charset="-120"/>
+              </a:rPr>
+              <a:t>Cuts exposure to negative-sentiment drawdowns while still capturing upside.</a:t>
+            </a:r>
+            <a:endParaRPr lang="en-US" sz="1400" dirty="0"/>
+          </a:p>
+        </p:txBody>
+      </p:sp>
+      <p:sp>
+        <p:nvSpPr>
+          <p:cNvPr id="18" name="Text 13"/>
+          <p:cNvSpPr txBox="1"/>
+          <p:nvPr/>
+        </p:nvSpPr>
+        <p:spPr>
+          <a:xfrm>
+            <a:off x="457200" y="4754880"/>
+            <a:ext cx="2743200" cy="228600"/>
+          </a:xfrm>
+          <a:prstGeom prst="rect">
+            <a:avLst/>
+          </a:prstGeom>
+          <a:noFill/>
+          <a:ln/>
+        </p:spPr>
+        <p:txBody>
+          <a:bodyPr wrap="square" lIns="0" tIns="0" rIns="0" bIns="0" rtlCol="0" anchor="ctr"/>
+          <a:lstStyle/>
+          <a:p>
+            <a:pPr marL="0" indent="0">
+              <a:buNone/>
+            </a:pPr>
+            <a:r>
+              <a:rPr lang="en-US" sz="1000" dirty="0">
+                <a:solidFill>
+                  <a:srgbClr val="475569"/>
+                </a:solidFill>
+                <a:latin typeface="Calibri" pitchFamily="34" charset="0"/>
+                <a:ea typeface="Calibri" pitchFamily="34" charset="-122"/>
+                <a:cs typeface="Calibri" pitchFamily="34" charset="-120"/>
+              </a:rPr>
               <a:t>SentinelRisk</a:t>
             </a:r>
             <a:endParaRPr lang="en-US" sz="1000" dirty="0"/>
@@ -3453,7 +3322,7 @@
           <a:bodyPr wrap="square" lIns="0" tIns="0" rIns="0" bIns="0" rtlCol="0" anchor="ctr"/>
           <a:lstStyle/>
           <a:p>
-            <a:pPr algn="r" indent="0" marL="0">
+            <a:pPr marL="0" indent="0" algn="r">
               <a:buNone/>
             </a:pPr>
             <a:r>
@@ -3487,6 +3356,7 @@
         <a:solidFill>
           <a:srgbClr val="FFFFFF"/>
         </a:solidFill>
+        <a:effectLst/>
       </p:bgPr>
     </p:bg>
     <p:spTree>
@@ -3524,7 +3394,7 @@
           <a:bodyPr wrap="square" lIns="0" tIns="0" rIns="0" bIns="0" rtlCol="0" anchor="ctr"/>
           <a:lstStyle/>
           <a:p>
-            <a:pPr indent="0" marL="0">
+            <a:pPr marL="0" indent="0">
               <a:buNone/>
             </a:pPr>
             <a:r>
@@ -3607,7 +3477,7 @@
           <a:bodyPr wrap="square" lIns="0" tIns="0" rIns="0" bIns="0" rtlCol="0" anchor="ctr"/>
           <a:lstStyle/>
           <a:p>
-            <a:pPr indent="0" marL="0">
+            <a:pPr marL="0" indent="0">
               <a:buNone/>
             </a:pPr>
             <a:r>
@@ -3666,7 +3536,7 @@
           <a:bodyPr wrap="square" lIns="0" tIns="0" rIns="0" bIns="0" rtlCol="0" anchor="t"/>
           <a:lstStyle/>
           <a:p>
-            <a:pPr indent="0" marL="0">
+            <a:pPr marL="0" indent="0">
               <a:buNone/>
             </a:pPr>
             <a:r>
@@ -3683,7 +3553,7 @@
             <a:endParaRPr lang="en-US" sz="1200" dirty="0"/>
           </a:p>
           <a:p>
-            <a:pPr indent="0" marL="0">
+            <a:pPr marL="0" indent="0">
               <a:buNone/>
             </a:pPr>
             <a:r>
@@ -3700,7 +3570,7 @@
             <a:endParaRPr lang="en-US" sz="1200" dirty="0"/>
           </a:p>
           <a:p>
-            <a:pPr indent="0" marL="0">
+            <a:pPr marL="0" indent="0">
               <a:buNone/>
             </a:pPr>
             <a:r>
@@ -3807,7 +3677,7 @@
           <a:bodyPr wrap="square" lIns="0" tIns="0" rIns="0" bIns="0" rtlCol="0" anchor="ctr"/>
           <a:lstStyle/>
           <a:p>
-            <a:pPr indent="0" marL="0">
+            <a:pPr marL="0" indent="0">
               <a:buNone/>
             </a:pPr>
             <a:r>
@@ -3866,7 +3736,7 @@
           <a:bodyPr wrap="square" lIns="0" tIns="0" rIns="0" bIns="0" rtlCol="0" anchor="t"/>
           <a:lstStyle/>
           <a:p>
-            <a:pPr indent="0" marL="0">
+            <a:pPr marL="0" indent="0">
               <a:buNone/>
             </a:pPr>
             <a:r>
@@ -3973,7 +3843,7 @@
           <a:bodyPr wrap="square" lIns="0" tIns="0" rIns="0" bIns="0" rtlCol="0" anchor="ctr"/>
           <a:lstStyle/>
           <a:p>
-            <a:pPr indent="0" marL="0">
+            <a:pPr marL="0" indent="0">
               <a:buNone/>
             </a:pPr>
             <a:r>
@@ -4032,7 +3902,7 @@
           <a:bodyPr wrap="square" lIns="0" tIns="0" rIns="0" bIns="0" rtlCol="0" anchor="t"/>
           <a:lstStyle/>
           <a:p>
-            <a:pPr indent="0" marL="0">
+            <a:pPr marL="0" indent="0">
               <a:buNone/>
             </a:pPr>
             <a:r>
@@ -4049,7 +3919,7 @@
             <a:endParaRPr lang="en-US" sz="1200" dirty="0"/>
           </a:p>
           <a:p>
-            <a:pPr indent="0" marL="0">
+            <a:pPr marL="0" indent="0">
               <a:buNone/>
             </a:pPr>
             <a:r>
@@ -4066,7 +3936,7 @@
             <a:endParaRPr lang="en-US" sz="1200" dirty="0"/>
           </a:p>
           <a:p>
-            <a:pPr indent="0" marL="0">
+            <a:pPr marL="0" indent="0">
               <a:buNone/>
             </a:pPr>
             <a:r>
@@ -4173,7 +4043,7 @@
           <a:bodyPr wrap="square" lIns="0" tIns="0" rIns="0" bIns="0" rtlCol="0" anchor="ctr"/>
           <a:lstStyle/>
           <a:p>
-            <a:pPr indent="0" marL="0">
+            <a:pPr marL="0" indent="0">
               <a:buNone/>
             </a:pPr>
             <a:r>
@@ -4232,7 +4102,7 @@
           <a:bodyPr wrap="square" lIns="0" tIns="0" rIns="0" bIns="0" rtlCol="0" anchor="t"/>
           <a:lstStyle/>
           <a:p>
-            <a:pPr indent="0" marL="0">
+            <a:pPr marL="0" indent="0">
               <a:buNone/>
             </a:pPr>
             <a:r>
@@ -4249,7 +4119,7 @@
             <a:endParaRPr lang="en-US" sz="1200" dirty="0"/>
           </a:p>
           <a:p>
-            <a:pPr indent="0" marL="0">
+            <a:pPr marL="0" indent="0">
               <a:buNone/>
             </a:pPr>
             <a:r>
@@ -4356,7 +4226,7 @@
           <a:bodyPr wrap="square" lIns="0" tIns="0" rIns="0" bIns="0" rtlCol="0" anchor="ctr"/>
           <a:lstStyle/>
           <a:p>
-            <a:pPr indent="0" marL="0">
+            <a:pPr marL="0" indent="0">
               <a:buNone/>
             </a:pPr>
             <a:r>
@@ -4415,7 +4285,7 @@
           <a:bodyPr wrap="square" lIns="0" tIns="0" rIns="0" bIns="0" rtlCol="0" anchor="t"/>
           <a:lstStyle/>
           <a:p>
-            <a:pPr indent="0" marL="0">
+            <a:pPr marL="0" indent="0">
               <a:buNone/>
             </a:pPr>
             <a:r>
@@ -4457,14 +4327,14 @@
       </p:sp>
       <p:pic>
         <p:nvPicPr>
-          <p:cNvPr id="33" name="Image 0" descr="preencoded.png">    </p:cNvPr>
+          <p:cNvPr id="33" name="Image 0" descr="preencoded.png"/>
           <p:cNvPicPr>
             <a:picLocks noChangeAspect="1"/>
           </p:cNvPicPr>
           <p:nvPr/>
         </p:nvPicPr>
         <p:blipFill>
-          <a:blip r:embed="rId1"/>
+          <a:blip r:embed="rId3"/>
           <a:stretch>
             <a:fillRect/>
           </a:stretch>
@@ -4500,7 +4370,7 @@
           <a:bodyPr wrap="square" lIns="0" tIns="0" rIns="0" bIns="0" rtlCol="0" anchor="ctr"/>
           <a:lstStyle/>
           <a:p>
-            <a:pPr indent="0" marL="0">
+            <a:pPr marL="0" indent="0">
               <a:buNone/>
             </a:pPr>
             <a:r>
@@ -4514,9 +4384,6 @@
               </a:rPr>
               <a:t>6  Dashboard  </a:t>
             </a:r>
-            <a:pPr indent="0" marL="0">
-              <a:buNone/>
-            </a:pPr>
             <a:r>
               <a:rPr lang="en-US" sz="1500" dirty="0">
                 <a:solidFill>
@@ -4553,7 +4420,7 @@
           <a:bodyPr wrap="square" lIns="0" tIns="0" rIns="0" bIns="0" rtlCol="0" anchor="ctr"/>
           <a:lstStyle/>
           <a:p>
-            <a:pPr indent="0" marL="0">
+            <a:pPr marL="0" indent="0">
               <a:buNone/>
             </a:pPr>
             <a:r>
@@ -4592,7 +4459,7 @@
           <a:bodyPr wrap="square" lIns="0" tIns="0" rIns="0" bIns="0" rtlCol="0" anchor="ctr"/>
           <a:lstStyle/>
           <a:p>
-            <a:pPr algn="r" indent="0" marL="0">
+            <a:pPr marL="0" indent="0" algn="r">
               <a:buNone/>
             </a:pPr>
             <a:r>
@@ -4626,6 +4493,7 @@
         <a:solidFill>
           <a:srgbClr val="FFFFFF"/>
         </a:solidFill>
+        <a:effectLst/>
       </p:bgPr>
     </p:bg>
     <p:spTree>
@@ -4663,7 +4531,7 @@
           <a:bodyPr wrap="square" lIns="0" tIns="0" rIns="0" bIns="0" rtlCol="0" anchor="ctr"/>
           <a:lstStyle/>
           <a:p>
-            <a:pPr indent="0" marL="0">
+            <a:pPr marL="0" indent="0">
               <a:buNone/>
             </a:pPr>
             <a:r>
@@ -4744,7 +4612,7 @@
           <a:bodyPr wrap="square" lIns="0" tIns="0" rIns="0" bIns="0" rtlCol="0" anchor="ctr"/>
           <a:lstStyle/>
           <a:p>
-            <a:pPr algn="ctr" indent="0" marL="0">
+            <a:pPr marL="0" indent="0" algn="ctr">
               <a:buNone/>
             </a:pPr>
             <a:r>
@@ -4783,7 +4651,7 @@
           <a:bodyPr wrap="square" lIns="0" tIns="0" rIns="0" bIns="0" rtlCol="0" anchor="ctr"/>
           <a:lstStyle/>
           <a:p>
-            <a:pPr indent="0" marL="0">
+            <a:pPr marL="0" indent="0">
               <a:buNone/>
             </a:pPr>
             <a:r>
@@ -4800,7 +4668,7 @@
             <a:endParaRPr lang="en-US" sz="1600" dirty="0"/>
           </a:p>
           <a:p>
-            <a:pPr indent="0" marL="0">
+            <a:pPr marL="0" indent="0">
               <a:buNone/>
             </a:pPr>
             <a:r>
@@ -4881,7 +4749,7 @@
           <a:bodyPr wrap="square" lIns="0" tIns="0" rIns="0" bIns="0" rtlCol="0" anchor="ctr"/>
           <a:lstStyle/>
           <a:p>
-            <a:pPr algn="ctr" indent="0" marL="0">
+            <a:pPr marL="0" indent="0" algn="ctr">
               <a:buNone/>
             </a:pPr>
             <a:r>
@@ -4920,7 +4788,7 @@
           <a:bodyPr wrap="square" lIns="0" tIns="0" rIns="0" bIns="0" rtlCol="0" anchor="ctr"/>
           <a:lstStyle/>
           <a:p>
-            <a:pPr indent="0" marL="0">
+            <a:pPr marL="0" indent="0">
               <a:buNone/>
             </a:pPr>
             <a:r>
@@ -4937,7 +4805,7 @@
             <a:endParaRPr lang="en-US" sz="1600" dirty="0"/>
           </a:p>
           <a:p>
-            <a:pPr indent="0" marL="0">
+            <a:pPr marL="0" indent="0">
               <a:buNone/>
             </a:pPr>
             <a:r>
@@ -5018,7 +4886,7 @@
           <a:bodyPr wrap="square" lIns="0" tIns="0" rIns="0" bIns="0" rtlCol="0" anchor="ctr"/>
           <a:lstStyle/>
           <a:p>
-            <a:pPr algn="ctr" indent="0" marL="0">
+            <a:pPr marL="0" indent="0" algn="ctr">
               <a:buNone/>
             </a:pPr>
             <a:r>
@@ -5057,7 +4925,7 @@
           <a:bodyPr wrap="square" lIns="0" tIns="0" rIns="0" bIns="0" rtlCol="0" anchor="ctr"/>
           <a:lstStyle/>
           <a:p>
-            <a:pPr indent="0" marL="0">
+            <a:pPr marL="0" indent="0">
               <a:buNone/>
             </a:pPr>
             <a:r>
@@ -5074,7 +4942,7 @@
             <a:endParaRPr lang="en-US" sz="1600" dirty="0"/>
           </a:p>
           <a:p>
-            <a:pPr indent="0" marL="0">
+            <a:pPr marL="0" indent="0">
               <a:buNone/>
             </a:pPr>
             <a:r>
@@ -5135,7 +5003,7 @@
           <a:bodyPr wrap="square" lIns="0" tIns="0" rIns="0" bIns="0" rtlCol="0" anchor="ctr"/>
           <a:lstStyle/>
           <a:p>
-            <a:pPr algn="ctr" indent="0" marL="0">
+            <a:pPr marL="0" indent="0" algn="ctr">
               <a:buNone/>
             </a:pPr>
             <a:r>
@@ -5174,7 +5042,7 @@
           <a:bodyPr wrap="square" lIns="0" tIns="0" rIns="0" bIns="0" rtlCol="0" anchor="ctr"/>
           <a:lstStyle/>
           <a:p>
-            <a:pPr indent="0" marL="0">
+            <a:pPr marL="0" indent="0">
               <a:buNone/>
             </a:pPr>
             <a:r>
@@ -5194,7 +5062,7 @@
       </p:sp>
       <p:graphicFrame>
         <p:nvGraphicFramePr>
-          <p:cNvPr id="18" name="Chart 0" descr=""/>
+          <p:cNvPr id="18" name="Chart 0"/>
           <p:cNvGraphicFramePr/>
           <p:nvPr/>
         </p:nvGraphicFramePr>
@@ -5202,9 +5070,9 @@
           <a:off x="4846320" y="1600200"/>
           <a:ext cx="3840480" cy="3017520"/>
         </p:xfrm>
-        <a:graphic xmlns:a="http://schemas.openxmlformats.org/drawingml/2006/main">
+        <a:graphic>
           <a:graphicData uri="http://schemas.openxmlformats.org/drawingml/2006/chart">
-            <c:chart xmlns:c="http://schemas.openxmlformats.org/drawingml/2006/chart" r:id="rId1"/>
+            <c:chart xmlns:c="http://schemas.openxmlformats.org/drawingml/2006/chart" xmlns:r="http://schemas.openxmlformats.org/officeDocument/2006/relationships" r:id="rId3"/>
           </a:graphicData>
         </a:graphic>
       </p:graphicFrame>
@@ -5229,7 +5097,7 @@
           <a:bodyPr wrap="square" lIns="0" tIns="0" rIns="0" bIns="0" rtlCol="0" anchor="ctr"/>
           <a:lstStyle/>
           <a:p>
-            <a:pPr indent="0" marL="0">
+            <a:pPr marL="0" indent="0">
               <a:buNone/>
             </a:pPr>
             <a:r>
@@ -5268,7 +5136,7 @@
           <a:bodyPr wrap="square" lIns="0" tIns="0" rIns="0" bIns="0" rtlCol="0" anchor="ctr"/>
           <a:lstStyle/>
           <a:p>
-            <a:pPr algn="r" indent="0" marL="0">
+            <a:pPr marL="0" indent="0" algn="r">
               <a:buNone/>
             </a:pPr>
             <a:r>
@@ -5302,6 +5170,7 @@
         <a:solidFill>
           <a:srgbClr val="FFFFFF"/>
         </a:solidFill>
+        <a:effectLst/>
       </p:bgPr>
     </p:bg>
     <p:spTree>
@@ -5339,7 +5208,7 @@
           <a:bodyPr wrap="square" lIns="0" tIns="0" rIns="0" bIns="0" rtlCol="0" anchor="ctr"/>
           <a:lstStyle/>
           <a:p>
-            <a:pPr indent="0" marL="0">
+            <a:pPr marL="0" indent="0">
               <a:buNone/>
             </a:pPr>
             <a:r>
@@ -5400,7 +5269,7 @@
           <a:bodyPr wrap="square" lIns="0" tIns="0" rIns="0" bIns="0" rtlCol="0" anchor="ctr"/>
           <a:lstStyle/>
           <a:p>
-            <a:pPr algn="ctr" indent="0" marL="0">
+            <a:pPr marL="0" indent="0" algn="ctr">
               <a:buNone/>
             </a:pPr>
             <a:r>
@@ -5417,7 +5286,7 @@
             <a:endParaRPr lang="en-US" sz="1500" dirty="0"/>
           </a:p>
           <a:p>
-            <a:pPr algn="ctr" indent="0" marL="0">
+            <a:pPr marL="0" indent="0" algn="ctr">
               <a:buNone/>
             </a:pPr>
             <a:r>
@@ -5502,7 +5371,7 @@
           <a:bodyPr wrap="square" lIns="0" tIns="0" rIns="0" bIns="0" rtlCol="0" anchor="ctr"/>
           <a:lstStyle/>
           <a:p>
-            <a:pPr algn="ctr" indent="0" marL="0">
+            <a:pPr marL="0" indent="0" algn="ctr">
               <a:buNone/>
             </a:pPr>
             <a:r>
@@ -5519,7 +5388,7 @@
             <a:endParaRPr lang="en-US" sz="1500" dirty="0"/>
           </a:p>
           <a:p>
-            <a:pPr algn="ctr" indent="0" marL="0">
+            <a:pPr marL="0" indent="0" algn="ctr">
               <a:buNone/>
             </a:pPr>
             <a:r>
@@ -5604,7 +5473,7 @@
           <a:bodyPr wrap="square" lIns="0" tIns="0" rIns="0" bIns="0" rtlCol="0" anchor="ctr"/>
           <a:lstStyle/>
           <a:p>
-            <a:pPr algn="ctr" indent="0" marL="0">
+            <a:pPr marL="0" indent="0" algn="ctr">
               <a:buNone/>
             </a:pPr>
             <a:r>
@@ -5621,7 +5490,7 @@
             <a:endParaRPr lang="en-US" sz="1500" dirty="0"/>
           </a:p>
           <a:p>
-            <a:pPr algn="ctr" indent="0" marL="0">
+            <a:pPr marL="0" indent="0" algn="ctr">
               <a:buNone/>
             </a:pPr>
             <a:r>
@@ -5706,7 +5575,7 @@
           <a:bodyPr wrap="square" lIns="0" tIns="0" rIns="0" bIns="0" rtlCol="0" anchor="ctr"/>
           <a:lstStyle/>
           <a:p>
-            <a:pPr algn="ctr" indent="0" marL="0">
+            <a:pPr marL="0" indent="0" algn="ctr">
               <a:buNone/>
             </a:pPr>
             <a:r>
@@ -5723,7 +5592,7 @@
             <a:endParaRPr lang="en-US" sz="1500" dirty="0"/>
           </a:p>
           <a:p>
-            <a:pPr algn="ctr" indent="0" marL="0">
+            <a:pPr marL="0" indent="0" algn="ctr">
               <a:buNone/>
             </a:pPr>
             <a:r>
@@ -5762,7 +5631,7 @@
           <a:bodyPr wrap="square" lIns="0" tIns="0" rIns="0" bIns="0" rtlCol="0" anchor="ctr"/>
           <a:lstStyle/>
           <a:p>
-            <a:pPr indent="0" marL="0">
+            <a:pPr marL="0" indent="0">
               <a:buNone/>
             </a:pPr>
             <a:r>
@@ -5883,7 +5752,7 @@
           <a:bodyPr wrap="square" lIns="0" tIns="0" rIns="0" bIns="0" rtlCol="0" anchor="ctr"/>
           <a:lstStyle/>
           <a:p>
-            <a:pPr algn="ctr" indent="0" marL="0">
+            <a:pPr marL="0" indent="0" algn="ctr">
               <a:buNone/>
             </a:pPr>
             <a:r>
@@ -5942,7 +5811,7 @@
           <a:bodyPr wrap="square" lIns="0" tIns="0" rIns="0" bIns="0" rtlCol="0" anchor="ctr"/>
           <a:lstStyle/>
           <a:p>
-            <a:pPr algn="ctr" indent="0" marL="0">
+            <a:pPr marL="0" indent="0" algn="ctr">
               <a:buNone/>
             </a:pPr>
             <a:r>
@@ -5981,7 +5850,7 @@
           <a:bodyPr wrap="square" lIns="0" tIns="0" rIns="0" bIns="0" rtlCol="0" anchor="ctr"/>
           <a:lstStyle/>
           <a:p>
-            <a:pPr algn="ctr" indent="0" marL="0">
+            <a:pPr marL="0" indent="0" algn="ctr">
               <a:buNone/>
             </a:pPr>
             <a:r>
@@ -6020,7 +5889,7 @@
           <a:bodyPr wrap="square" lIns="0" tIns="0" rIns="0" bIns="0" rtlCol="0" anchor="ctr"/>
           <a:lstStyle/>
           <a:p>
-            <a:pPr algn="ctr" indent="0" marL="0">
+            <a:pPr marL="0" indent="0" algn="ctr">
               <a:buNone/>
             </a:pPr>
             <a:r>
@@ -6059,7 +5928,7 @@
           <a:bodyPr wrap="square" lIns="0" tIns="0" rIns="0" bIns="0" rtlCol="0" anchor="ctr"/>
           <a:lstStyle/>
           <a:p>
-            <a:pPr indent="0" marL="0">
+            <a:pPr marL="0" indent="0">
               <a:buNone/>
             </a:pPr>
             <a:r>
@@ -6098,7 +5967,7 @@
           <a:bodyPr wrap="square" lIns="0" tIns="0" rIns="0" bIns="0" rtlCol="0" anchor="ctr"/>
           <a:lstStyle/>
           <a:p>
-            <a:pPr indent="0" marL="0">
+            <a:pPr marL="0" indent="0">
               <a:buNone/>
             </a:pPr>
             <a:r>
@@ -6137,7 +6006,7 @@
           <a:bodyPr wrap="square" lIns="0" tIns="0" rIns="0" bIns="0" rtlCol="0" anchor="ctr"/>
           <a:lstStyle/>
           <a:p>
-            <a:pPr algn="r" indent="0" marL="0">
+            <a:pPr marL="0" indent="0" algn="r">
               <a:buNone/>
             </a:pPr>
             <a:r>
@@ -6171,6 +6040,7 @@
         <a:solidFill>
           <a:srgbClr val="0A1628"/>
         </a:solidFill>
+        <a:effectLst/>
       </p:bgPr>
     </p:bg>
     <p:spTree>
@@ -6208,7 +6078,7 @@
           <a:bodyPr wrap="square" lIns="0" tIns="0" rIns="0" bIns="0" rtlCol="0" anchor="ctr"/>
           <a:lstStyle/>
           <a:p>
-            <a:pPr indent="0" marL="0">
+            <a:pPr marL="0" indent="0">
               <a:buNone/>
             </a:pPr>
             <a:r>
@@ -6250,7 +6120,7 @@
       </p:sp>
       <p:graphicFrame>
         <p:nvGraphicFramePr>
-          <p:cNvPr id="4" name="Chart 0" descr=""/>
+          <p:cNvPr id="4" name="Chart 0"/>
           <p:cNvGraphicFramePr/>
           <p:nvPr/>
         </p:nvGraphicFramePr>
@@ -6258,9 +6128,9 @@
           <a:off x="548640" y="1280160"/>
           <a:ext cx="4023360" cy="3154680"/>
         </p:xfrm>
-        <a:graphic xmlns:a="http://schemas.openxmlformats.org/drawingml/2006/main">
+        <a:graphic>
           <a:graphicData uri="http://schemas.openxmlformats.org/drawingml/2006/chart">
-            <c:chart xmlns:c="http://schemas.openxmlformats.org/drawingml/2006/chart" r:id="rId1"/>
+            <c:chart xmlns:c="http://schemas.openxmlformats.org/drawingml/2006/chart" xmlns:r="http://schemas.openxmlformats.org/officeDocument/2006/relationships" r:id="rId3"/>
           </a:graphicData>
         </a:graphic>
       </p:graphicFrame>
@@ -6307,7 +6177,7 @@
           <a:bodyPr wrap="square" lIns="0" tIns="0" rIns="0" bIns="0" rtlCol="0" anchor="ctr"/>
           <a:lstStyle/>
           <a:p>
-            <a:pPr indent="0" marL="0">
+            <a:pPr marL="0" indent="0">
               <a:buNone/>
             </a:pPr>
             <a:r>
@@ -6346,7 +6216,7 @@
           <a:bodyPr wrap="square" lIns="0" tIns="0" rIns="0" bIns="0" rtlCol="0" anchor="ctr"/>
           <a:lstStyle/>
           <a:p>
-            <a:pPr indent="0" marL="0">
+            <a:pPr marL="0" indent="0">
               <a:buNone/>
             </a:pPr>
             <a:r>
@@ -6407,7 +6277,7 @@
           <a:bodyPr wrap="square" lIns="0" tIns="0" rIns="0" bIns="0" rtlCol="0" anchor="ctr"/>
           <a:lstStyle/>
           <a:p>
-            <a:pPr indent="0" marL="0">
+            <a:pPr marL="0" indent="0">
               <a:buNone/>
             </a:pPr>
             <a:r>
@@ -6446,7 +6316,7 @@
           <a:bodyPr wrap="square" lIns="0" tIns="0" rIns="0" bIns="0" rtlCol="0" anchor="ctr"/>
           <a:lstStyle/>
           <a:p>
-            <a:pPr indent="0" marL="0">
+            <a:pPr marL="0" indent="0">
               <a:buNone/>
             </a:pPr>
             <a:r>
@@ -6507,7 +6377,7 @@
           <a:bodyPr wrap="square" lIns="0" tIns="0" rIns="0" bIns="0" rtlCol="0" anchor="ctr"/>
           <a:lstStyle/>
           <a:p>
-            <a:pPr indent="0" marL="0">
+            <a:pPr marL="0" indent="0">
               <a:buNone/>
             </a:pPr>
             <a:r>
@@ -6546,7 +6416,7 @@
           <a:bodyPr wrap="square" lIns="0" tIns="0" rIns="0" bIns="0" rtlCol="0" anchor="ctr"/>
           <a:lstStyle/>
           <a:p>
-            <a:pPr indent="0" marL="0">
+            <a:pPr marL="0" indent="0">
               <a:buNone/>
             </a:pPr>
             <a:r>
@@ -6607,7 +6477,7 @@
           <a:bodyPr wrap="square" lIns="0" tIns="0" rIns="0" bIns="0" rtlCol="0" anchor="ctr"/>
           <a:lstStyle/>
           <a:p>
-            <a:pPr indent="0" marL="0">
+            <a:pPr marL="0" indent="0">
               <a:buNone/>
             </a:pPr>
             <a:r>
@@ -6646,7 +6516,7 @@
           <a:bodyPr wrap="square" lIns="0" tIns="0" rIns="0" bIns="0" rtlCol="0" anchor="ctr"/>
           <a:lstStyle/>
           <a:p>
-            <a:pPr indent="0" marL="0">
+            <a:pPr marL="0" indent="0">
               <a:buNone/>
             </a:pPr>
             <a:r>
@@ -6707,7 +6577,7 @@
           <a:bodyPr wrap="square" lIns="0" tIns="0" rIns="0" bIns="0" rtlCol="0" anchor="ctr"/>
           <a:lstStyle/>
           <a:p>
-            <a:pPr indent="0" marL="0">
+            <a:pPr marL="0" indent="0">
               <a:buNone/>
             </a:pPr>
             <a:r>
@@ -6746,7 +6616,7 @@
           <a:bodyPr wrap="square" lIns="0" tIns="0" rIns="0" bIns="0" rtlCol="0" anchor="ctr"/>
           <a:lstStyle/>
           <a:p>
-            <a:pPr indent="0" marL="0">
+            <a:pPr marL="0" indent="0">
               <a:buNone/>
             </a:pPr>
             <a:r>
@@ -6785,7 +6655,7 @@
           <a:bodyPr wrap="square" lIns="0" tIns="0" rIns="0" bIns="0" rtlCol="0" anchor="ctr"/>
           <a:lstStyle/>
           <a:p>
-            <a:pPr algn="r" indent="0" marL="0">
+            <a:pPr marL="0" indent="0" algn="r">
               <a:buNone/>
             </a:pPr>
             <a:r>
@@ -6819,6 +6689,7 @@
         <a:solidFill>
           <a:srgbClr val="FFFFFF"/>
         </a:solidFill>
+        <a:effectLst/>
       </p:bgPr>
     </p:bg>
     <p:spTree>
@@ -6856,7 +6727,7 @@
           <a:bodyPr wrap="square" lIns="0" tIns="0" rIns="0" bIns="0" rtlCol="0" anchor="ctr"/>
           <a:lstStyle/>
           <a:p>
-            <a:pPr indent="0" marL="0">
+            <a:pPr marL="0" indent="0">
               <a:buNone/>
             </a:pPr>
             <a:r>
@@ -6917,7 +6788,7 @@
           <a:bodyPr wrap="square" lIns="0" tIns="0" rIns="0" bIns="0" rtlCol="0" anchor="ctr"/>
           <a:lstStyle/>
           <a:p>
-            <a:pPr indent="0" marL="0">
+            <a:pPr marL="0" indent="0">
               <a:buNone/>
             </a:pPr>
             <a:r>
@@ -7002,7 +6873,7 @@
           <a:bodyPr wrap="square" lIns="0" tIns="0" rIns="0" bIns="0" rtlCol="0" anchor="ctr"/>
           <a:lstStyle/>
           <a:p>
-            <a:pPr indent="0" marL="0">
+            <a:pPr marL="0" indent="0">
               <a:buNone/>
             </a:pPr>
             <a:r>
@@ -7063,7 +6934,7 @@
           <a:bodyPr wrap="square" lIns="0" tIns="0" rIns="0" bIns="0" rtlCol="0" anchor="ctr"/>
           <a:lstStyle/>
           <a:p>
-            <a:pPr indent="0" marL="0">
+            <a:pPr marL="0" indent="0">
               <a:buNone/>
             </a:pPr>
             <a:r>
@@ -7148,7 +7019,7 @@
           <a:bodyPr wrap="square" lIns="0" tIns="0" rIns="0" bIns="0" rtlCol="0" anchor="ctr"/>
           <a:lstStyle/>
           <a:p>
-            <a:pPr indent="0" marL="0">
+            <a:pPr marL="0" indent="0">
               <a:buNone/>
             </a:pPr>
             <a:r>
@@ -7209,7 +7080,7 @@
           <a:bodyPr wrap="square" lIns="0" tIns="0" rIns="0" bIns="0" rtlCol="0" anchor="ctr"/>
           <a:lstStyle/>
           <a:p>
-            <a:pPr indent="0" marL="0">
+            <a:pPr marL="0" indent="0">
               <a:buNone/>
             </a:pPr>
             <a:r>
@@ -7294,7 +7165,7 @@
           <a:bodyPr wrap="square" lIns="0" tIns="0" rIns="0" bIns="0" rtlCol="0" anchor="ctr"/>
           <a:lstStyle/>
           <a:p>
-            <a:pPr indent="0" marL="0">
+            <a:pPr marL="0" indent="0">
               <a:buNone/>
             </a:pPr>
             <a:r>
@@ -7355,7 +7226,7 @@
           <a:bodyPr wrap="square" lIns="0" tIns="0" rIns="0" bIns="0" rtlCol="0" anchor="ctr"/>
           <a:lstStyle/>
           <a:p>
-            <a:pPr indent="0" marL="0">
+            <a:pPr marL="0" indent="0">
               <a:buNone/>
             </a:pPr>
             <a:r>
@@ -7440,7 +7311,7 @@
           <a:bodyPr wrap="square" lIns="0" tIns="0" rIns="0" bIns="0" rtlCol="0" anchor="ctr"/>
           <a:lstStyle/>
           <a:p>
-            <a:pPr indent="0" marL="0">
+            <a:pPr marL="0" indent="0">
               <a:buNone/>
             </a:pPr>
             <a:r>
@@ -7501,7 +7372,7 @@
           <a:bodyPr wrap="square" lIns="0" tIns="0" rIns="0" bIns="0" rtlCol="0" anchor="ctr"/>
           <a:lstStyle/>
           <a:p>
-            <a:pPr indent="0" marL="0">
+            <a:pPr marL="0" indent="0">
               <a:buNone/>
             </a:pPr>
             <a:r>
@@ -7586,7 +7457,7 @@
           <a:bodyPr wrap="square" lIns="0" tIns="0" rIns="0" bIns="0" rtlCol="0" anchor="ctr"/>
           <a:lstStyle/>
           <a:p>
-            <a:pPr indent="0" marL="0">
+            <a:pPr marL="0" indent="0">
               <a:buNone/>
             </a:pPr>
             <a:r>
@@ -7625,7 +7496,7 @@
           <a:bodyPr wrap="square" lIns="0" tIns="0" rIns="0" bIns="0" rtlCol="0" anchor="ctr"/>
           <a:lstStyle/>
           <a:p>
-            <a:pPr indent="0" marL="0">
+            <a:pPr marL="0" indent="0">
               <a:buNone/>
             </a:pPr>
             <a:r>
@@ -7664,7 +7535,7 @@
           <a:bodyPr wrap="square" lIns="0" tIns="0" rIns="0" bIns="0" rtlCol="0" anchor="ctr"/>
           <a:lstStyle/>
           <a:p>
-            <a:pPr algn="r" indent="0" marL="0">
+            <a:pPr marL="0" indent="0" algn="r">
               <a:buNone/>
             </a:pPr>
             <a:r>
@@ -7698,6 +7569,7 @@
         <a:solidFill>
           <a:srgbClr val="FFFFFF"/>
         </a:solidFill>
+        <a:effectLst/>
       </p:bgPr>
     </p:bg>
     <p:spTree>
@@ -7735,7 +7607,7 @@
           <a:bodyPr wrap="square" lIns="0" tIns="0" rIns="0" bIns="0" rtlCol="0" anchor="ctr"/>
           <a:lstStyle/>
           <a:p>
-            <a:pPr indent="0" marL="0">
+            <a:pPr marL="0" indent="0">
               <a:buNone/>
             </a:pPr>
             <a:r>
@@ -7798,251 +7670,7 @@
       </p:sp>
       <p:pic>
         <p:nvPicPr>
-          <p:cNvPr id="5" name="Image 0" descr="preencoded.png">    </p:cNvPr>
-          <p:cNvPicPr>
-            <a:picLocks noChangeAspect="1"/>
-          </p:cNvPicPr>
-          <p:nvPr/>
-        </p:nvPicPr>
-        <p:blipFill>
-          <a:blip r:embed="rId1"/>
-          <a:stretch>
-            <a:fillRect/>
-          </a:stretch>
-        </p:blipFill>
-        <p:spPr>
-          <a:xfrm>
-            <a:off x="1115568" y="1664208"/>
-            <a:ext cx="420624" cy="420624"/>
-          </a:xfrm>
-          <a:prstGeom prst="rect">
-            <a:avLst/>
-          </a:prstGeom>
-        </p:spPr>
-      </p:pic>
-      <p:sp>
-        <p:nvSpPr>
-          <p:cNvPr id="6" name="Text 3"/>
-          <p:cNvSpPr txBox="1"/>
-          <p:nvPr/>
-        </p:nvSpPr>
-        <p:spPr>
-          <a:xfrm>
-            <a:off x="457200" y="2468880"/>
-            <a:ext cx="1600200" cy="502920"/>
-          </a:xfrm>
-          <a:prstGeom prst="rect">
-            <a:avLst/>
-          </a:prstGeom>
-          <a:noFill/>
-          <a:ln/>
-        </p:spPr>
-        <p:txBody>
-          <a:bodyPr wrap="square" lIns="0" tIns="0" rIns="0" bIns="0" rtlCol="0" anchor="t"/>
-          <a:lstStyle/>
-          <a:p>
-            <a:pPr algn="ctr" indent="0" marL="0">
-              <a:buNone/>
-            </a:pPr>
-            <a:r>
-              <a:rPr lang="en-US" sz="1500" b="1" dirty="0">
-                <a:solidFill>
-                  <a:srgbClr val="0A1628"/>
-                </a:solidFill>
-                <a:latin typeface="Cambria" pitchFamily="34" charset="0"/>
-                <a:ea typeface="Cambria" pitchFamily="34" charset="-122"/>
-                <a:cs typeface="Cambria" pitchFamily="34" charset="-120"/>
-              </a:rPr>
-              <a:t>Module B</a:t>
-            </a:r>
-            <a:endParaRPr lang="en-US" sz="1500" dirty="0"/>
-          </a:p>
-        </p:txBody>
-      </p:sp>
-      <p:sp>
-        <p:nvSpPr>
-          <p:cNvPr id="7" name="Text 4"/>
-          <p:cNvSpPr txBox="1"/>
-          <p:nvPr/>
-        </p:nvSpPr>
-        <p:spPr>
-          <a:xfrm>
-            <a:off x="457200" y="3017520"/>
-            <a:ext cx="1600200" cy="1097280"/>
-          </a:xfrm>
-          <a:prstGeom prst="rect">
-            <a:avLst/>
-          </a:prstGeom>
-          <a:noFill/>
-          <a:ln/>
-        </p:spPr>
-        <p:txBody>
-          <a:bodyPr wrap="square" lIns="0" tIns="0" rIns="0" bIns="0" rtlCol="0" anchor="t"/>
-          <a:lstStyle/>
-          <a:p>
-            <a:pPr algn="ctr" indent="0" marL="0">
-              <a:buNone/>
-            </a:pPr>
-            <a:r>
-              <a:rPr lang="en-US" sz="1300" dirty="0">
-                <a:solidFill>
-                  <a:srgbClr val="475569"/>
-                </a:solidFill>
-                <a:latin typeface="Calibri" pitchFamily="34" charset="0"/>
-                <a:ea typeface="Calibri" pitchFamily="34" charset="-122"/>
-                <a:cs typeface="Calibri" pitchFamily="34" charset="-120"/>
-              </a:rPr>
-              <a:t>Stress tests triggered by events with Impact &gt; 7</a:t>
-            </a:r>
-            <a:endParaRPr lang="en-US" sz="1300" dirty="0"/>
-          </a:p>
-        </p:txBody>
-      </p:sp>
-      <p:sp>
-        <p:nvSpPr>
-          <p:cNvPr id="8" name="Shape 5"/>
-          <p:cNvSpPr/>
-          <p:nvPr/>
-        </p:nvSpPr>
-        <p:spPr>
-          <a:xfrm>
-            <a:off x="2606040" y="1463040"/>
-            <a:ext cx="822960" cy="822960"/>
-          </a:xfrm>
-          <a:prstGeom prst="ellipse">
-            <a:avLst/>
-          </a:prstGeom>
-          <a:solidFill>
-            <a:srgbClr val="0A1628"/>
-          </a:solidFill>
-          <a:ln/>
-        </p:spPr>
-      </p:sp>
-      <p:pic>
-        <p:nvPicPr>
-          <p:cNvPr id="9" name="Image 1" descr="preencoded.png">    </p:cNvPr>
-          <p:cNvPicPr>
-            <a:picLocks noChangeAspect="1"/>
-          </p:cNvPicPr>
-          <p:nvPr/>
-        </p:nvPicPr>
-        <p:blipFill>
-          <a:blip r:embed="rId2"/>
-          <a:stretch>
-            <a:fillRect/>
-          </a:stretch>
-        </p:blipFill>
-        <p:spPr>
-          <a:xfrm>
-            <a:off x="2807208" y="1664208"/>
-            <a:ext cx="420624" cy="420624"/>
-          </a:xfrm>
-          <a:prstGeom prst="rect">
-            <a:avLst/>
-          </a:prstGeom>
-        </p:spPr>
-      </p:pic>
-      <p:sp>
-        <p:nvSpPr>
-          <p:cNvPr id="10" name="Text 6"/>
-          <p:cNvSpPr txBox="1"/>
-          <p:nvPr/>
-        </p:nvSpPr>
-        <p:spPr>
-          <a:xfrm>
-            <a:off x="2148840" y="2468880"/>
-            <a:ext cx="1600200" cy="502920"/>
-          </a:xfrm>
-          <a:prstGeom prst="rect">
-            <a:avLst/>
-          </a:prstGeom>
-          <a:noFill/>
-          <a:ln/>
-        </p:spPr>
-        <p:txBody>
-          <a:bodyPr wrap="square" lIns="0" tIns="0" rIns="0" bIns="0" rtlCol="0" anchor="t"/>
-          <a:lstStyle/>
-          <a:p>
-            <a:pPr algn="ctr" indent="0" marL="0">
-              <a:buNone/>
-            </a:pPr>
-            <a:r>
-              <a:rPr lang="en-US" sz="1500" b="1" dirty="0">
-                <a:solidFill>
-                  <a:srgbClr val="0A1628"/>
-                </a:solidFill>
-                <a:latin typeface="Cambria" pitchFamily="34" charset="0"/>
-                <a:ea typeface="Cambria" pitchFamily="34" charset="-122"/>
-                <a:cs typeface="Cambria" pitchFamily="34" charset="-120"/>
-              </a:rPr>
-              <a:t>GDELT</a:t>
-            </a:r>
-            <a:endParaRPr lang="en-US" sz="1500" dirty="0"/>
-          </a:p>
-        </p:txBody>
-      </p:sp>
-      <p:sp>
-        <p:nvSpPr>
-          <p:cNvPr id="11" name="Text 7"/>
-          <p:cNvSpPr txBox="1"/>
-          <p:nvPr/>
-        </p:nvSpPr>
-        <p:spPr>
-          <a:xfrm>
-            <a:off x="2148840" y="3017520"/>
-            <a:ext cx="1600200" cy="1097280"/>
-          </a:xfrm>
-          <a:prstGeom prst="rect">
-            <a:avLst/>
-          </a:prstGeom>
-          <a:noFill/>
-          <a:ln/>
-        </p:spPr>
-        <p:txBody>
-          <a:bodyPr wrap="square" lIns="0" tIns="0" rIns="0" bIns="0" rtlCol="0" anchor="t"/>
-          <a:lstStyle/>
-          <a:p>
-            <a:pPr algn="ctr" indent="0" marL="0">
-              <a:buNone/>
-            </a:pPr>
-            <a:r>
-              <a:rPr lang="en-US" sz="1300" dirty="0">
-                <a:solidFill>
-                  <a:srgbClr val="475569"/>
-                </a:solidFill>
-                <a:latin typeface="Calibri" pitchFamily="34" charset="0"/>
-                <a:ea typeface="Calibri" pitchFamily="34" charset="-122"/>
-                <a:cs typeface="Calibri" pitchFamily="34" charset="-120"/>
-              </a:rPr>
-              <a:t>Macro and geopolitical news coverage</a:t>
-            </a:r>
-            <a:endParaRPr lang="en-US" sz="1300" dirty="0"/>
-          </a:p>
-        </p:txBody>
-      </p:sp>
-      <p:sp>
-        <p:nvSpPr>
-          <p:cNvPr id="12" name="Shape 8"/>
-          <p:cNvSpPr/>
-          <p:nvPr/>
-        </p:nvSpPr>
-        <p:spPr>
-          <a:xfrm>
-            <a:off x="4297680" y="1463040"/>
-            <a:ext cx="822960" cy="822960"/>
-          </a:xfrm>
-          <a:prstGeom prst="ellipse">
-            <a:avLst/>
-          </a:prstGeom>
-          <a:solidFill>
-            <a:srgbClr val="0A1628"/>
-          </a:solidFill>
-          <a:ln/>
-        </p:spPr>
-      </p:sp>
-      <p:pic>
-        <p:nvPicPr>
-          <p:cNvPr id="13" name="Image 2" descr="preencoded.png">    </p:cNvPr>
+          <p:cNvPr id="5" name="Image 0" descr="preencoded.png"/>
           <p:cNvPicPr>
             <a:picLocks noChangeAspect="1"/>
           </p:cNvPicPr>
@@ -8056,7 +7684,7 @@
         </p:blipFill>
         <p:spPr>
           <a:xfrm>
-            <a:off x="4498848" y="1664208"/>
+            <a:off x="1115568" y="1664208"/>
             <a:ext cx="420624" cy="420624"/>
           </a:xfrm>
           <a:prstGeom prst="rect">
@@ -8066,13 +7694,13 @@
       </p:pic>
       <p:sp>
         <p:nvSpPr>
-          <p:cNvPr id="14" name="Text 9"/>
-          <p:cNvSpPr txBox="1"/>
-          <p:nvPr/>
-        </p:nvSpPr>
-        <p:spPr>
-          <a:xfrm>
-            <a:off x="3840480" y="2468880"/>
+          <p:cNvPr id="6" name="Text 3"/>
+          <p:cNvSpPr txBox="1"/>
+          <p:nvPr/>
+        </p:nvSpPr>
+        <p:spPr>
+          <a:xfrm>
+            <a:off x="457200" y="2468880"/>
             <a:ext cx="1600200" cy="502920"/>
           </a:xfrm>
           <a:prstGeom prst="rect">
@@ -8085,7 +7713,7 @@
           <a:bodyPr wrap="square" lIns="0" tIns="0" rIns="0" bIns="0" rtlCol="0" anchor="t"/>
           <a:lstStyle/>
           <a:p>
-            <a:pPr algn="ctr" indent="0" marL="0">
+            <a:pPr marL="0" indent="0" algn="ctr">
               <a:buNone/>
             </a:pPr>
             <a:r>
@@ -8097,7 +7725,7 @@
                 <a:ea typeface="Cambria" pitchFamily="34" charset="-122"/>
                 <a:cs typeface="Cambria" pitchFamily="34" charset="-120"/>
               </a:rPr>
-              <a:t>Kafka</a:t>
+              <a:t>Module B</a:t>
             </a:r>
             <a:endParaRPr lang="en-US" sz="1500" dirty="0"/>
           </a:p>
@@ -8105,13 +7733,13 @@
       </p:sp>
       <p:sp>
         <p:nvSpPr>
-          <p:cNvPr id="15" name="Text 10"/>
-          <p:cNvSpPr txBox="1"/>
-          <p:nvPr/>
-        </p:nvSpPr>
-        <p:spPr>
-          <a:xfrm>
-            <a:off x="3840480" y="3017520"/>
+          <p:cNvPr id="7" name="Text 4"/>
+          <p:cNvSpPr txBox="1"/>
+          <p:nvPr/>
+        </p:nvSpPr>
+        <p:spPr>
+          <a:xfrm>
+            <a:off x="457200" y="3017520"/>
             <a:ext cx="1600200" cy="1097280"/>
           </a:xfrm>
           <a:prstGeom prst="rect">
@@ -8124,7 +7752,7 @@
           <a:bodyPr wrap="square" lIns="0" tIns="0" rIns="0" bIns="0" rtlCol="0" anchor="t"/>
           <a:lstStyle/>
           <a:p>
-            <a:pPr algn="ctr" indent="0" marL="0">
+            <a:pPr marL="0" indent="0" algn="ctr">
               <a:buNone/>
             </a:pPr>
             <a:r>
@@ -8136,7 +7764,7 @@
                 <a:ea typeface="Calibri" pitchFamily="34" charset="-122"/>
                 <a:cs typeface="Calibri" pitchFamily="34" charset="-120"/>
               </a:rPr>
-              <a:t>Streaming pipeline for real-time scale</a:t>
+              <a:t>Stress tests triggered by events with Impact &gt; 7</a:t>
             </a:r>
             <a:endParaRPr lang="en-US" sz="1300" dirty="0"/>
           </a:p>
@@ -8144,13 +7772,13 @@
       </p:sp>
       <p:sp>
         <p:nvSpPr>
-          <p:cNvPr id="16" name="Shape 11"/>
+          <p:cNvPr id="8" name="Shape 5"/>
           <p:cNvSpPr/>
           <p:nvPr/>
         </p:nvSpPr>
         <p:spPr>
           <a:xfrm>
-            <a:off x="5989320" y="1463040"/>
+            <a:off x="2606040" y="1463040"/>
             <a:ext cx="822960" cy="822960"/>
           </a:xfrm>
           <a:prstGeom prst="ellipse">
@@ -8164,7 +7792,7 @@
       </p:sp>
       <p:pic>
         <p:nvPicPr>
-          <p:cNvPr id="17" name="Image 3" descr="preencoded.png">    </p:cNvPr>
+          <p:cNvPr id="9" name="Image 1" descr="preencoded.png"/>
           <p:cNvPicPr>
             <a:picLocks noChangeAspect="1"/>
           </p:cNvPicPr>
@@ -8178,7 +7806,7 @@
         </p:blipFill>
         <p:spPr>
           <a:xfrm>
-            <a:off x="6190488" y="1664208"/>
+            <a:off x="2807208" y="1664208"/>
             <a:ext cx="420624" cy="420624"/>
           </a:xfrm>
           <a:prstGeom prst="rect">
@@ -8188,13 +7816,13 @@
       </p:pic>
       <p:sp>
         <p:nvSpPr>
-          <p:cNvPr id="18" name="Text 12"/>
-          <p:cNvSpPr txBox="1"/>
-          <p:nvPr/>
-        </p:nvSpPr>
-        <p:spPr>
-          <a:xfrm>
-            <a:off x="5532120" y="2468880"/>
+          <p:cNvPr id="10" name="Text 6"/>
+          <p:cNvSpPr txBox="1"/>
+          <p:nvPr/>
+        </p:nvSpPr>
+        <p:spPr>
+          <a:xfrm>
+            <a:off x="2148840" y="2468880"/>
             <a:ext cx="1600200" cy="502920"/>
           </a:xfrm>
           <a:prstGeom prst="rect">
@@ -8207,7 +7835,7 @@
           <a:bodyPr wrap="square" lIns="0" tIns="0" rIns="0" bIns="0" rtlCol="0" anchor="t"/>
           <a:lstStyle/>
           <a:p>
-            <a:pPr algn="ctr" indent="0" marL="0">
+            <a:pPr marL="0" indent="0" algn="ctr">
               <a:buNone/>
             </a:pPr>
             <a:r>
@@ -8219,7 +7847,7 @@
                 <a:ea typeface="Cambria" pitchFamily="34" charset="-122"/>
                 <a:cs typeface="Cambria" pitchFamily="34" charset="-120"/>
               </a:rPr>
-              <a:t>Fine-tuned FinBERT</a:t>
+              <a:t>GDELT</a:t>
             </a:r>
             <a:endParaRPr lang="en-US" sz="1500" dirty="0"/>
           </a:p>
@@ -8227,13 +7855,13 @@
       </p:sp>
       <p:sp>
         <p:nvSpPr>
-          <p:cNvPr id="19" name="Text 13"/>
-          <p:cNvSpPr txBox="1"/>
-          <p:nvPr/>
-        </p:nvSpPr>
-        <p:spPr>
-          <a:xfrm>
-            <a:off x="5532120" y="3017520"/>
+          <p:cNvPr id="11" name="Text 7"/>
+          <p:cNvSpPr txBox="1"/>
+          <p:nvPr/>
+        </p:nvSpPr>
+        <p:spPr>
+          <a:xfrm>
+            <a:off x="2148840" y="3017520"/>
             <a:ext cx="1600200" cy="1097280"/>
           </a:xfrm>
           <a:prstGeom prst="rect">
@@ -8246,7 +7874,7 @@
           <a:bodyPr wrap="square" lIns="0" tIns="0" rIns="0" bIns="0" rtlCol="0" anchor="t"/>
           <a:lstStyle/>
           <a:p>
-            <a:pPr algn="ctr" indent="0" marL="0">
+            <a:pPr marL="0" indent="0" algn="ctr">
               <a:buNone/>
             </a:pPr>
             <a:r>
@@ -8258,7 +7886,7 @@
                 <a:ea typeface="Calibri" pitchFamily="34" charset="-122"/>
                 <a:cs typeface="Calibri" pitchFamily="34" charset="-120"/>
               </a:rPr>
-              <a:t>Trained on proprietary data</a:t>
+              <a:t>Macro and geopolitical news coverage</a:t>
             </a:r>
             <a:endParaRPr lang="en-US" sz="1300" dirty="0"/>
           </a:p>
@@ -8266,13 +7894,13 @@
       </p:sp>
       <p:sp>
         <p:nvSpPr>
-          <p:cNvPr id="20" name="Shape 14"/>
+          <p:cNvPr id="12" name="Shape 8"/>
           <p:cNvSpPr/>
           <p:nvPr/>
         </p:nvSpPr>
         <p:spPr>
           <a:xfrm>
-            <a:off x="7680960" y="1463040"/>
+            <a:off x="4297680" y="1463040"/>
             <a:ext cx="822960" cy="822960"/>
           </a:xfrm>
           <a:prstGeom prst="ellipse">
@@ -8286,7 +7914,7 @@
       </p:sp>
       <p:pic>
         <p:nvPicPr>
-          <p:cNvPr id="21" name="Image 4" descr="preencoded.png">    </p:cNvPr>
+          <p:cNvPr id="13" name="Image 2" descr="preencoded.png"/>
           <p:cNvPicPr>
             <a:picLocks noChangeAspect="1"/>
           </p:cNvPicPr>
@@ -8300,7 +7928,7 @@
         </p:blipFill>
         <p:spPr>
           <a:xfrm>
-            <a:off x="7882128" y="1664208"/>
+            <a:off x="4498848" y="1664208"/>
             <a:ext cx="420624" cy="420624"/>
           </a:xfrm>
           <a:prstGeom prst="rect">
@@ -8310,13 +7938,13 @@
       </p:pic>
       <p:sp>
         <p:nvSpPr>
-          <p:cNvPr id="22" name="Text 15"/>
-          <p:cNvSpPr txBox="1"/>
-          <p:nvPr/>
-        </p:nvSpPr>
-        <p:spPr>
-          <a:xfrm>
-            <a:off x="7223760" y="2468880"/>
+          <p:cNvPr id="14" name="Text 9"/>
+          <p:cNvSpPr txBox="1"/>
+          <p:nvPr/>
+        </p:nvSpPr>
+        <p:spPr>
+          <a:xfrm>
+            <a:off x="3840480" y="2468880"/>
             <a:ext cx="1600200" cy="502920"/>
           </a:xfrm>
           <a:prstGeom prst="rect">
@@ -8329,7 +7957,7 @@
           <a:bodyPr wrap="square" lIns="0" tIns="0" rIns="0" bIns="0" rtlCol="0" anchor="t"/>
           <a:lstStyle/>
           <a:p>
-            <a:pPr algn="ctr" indent="0" marL="0">
+            <a:pPr marL="0" indent="0" algn="ctr">
               <a:buNone/>
             </a:pPr>
             <a:r>
@@ -8341,7 +7969,7 @@
                 <a:ea typeface="Cambria" pitchFamily="34" charset="-122"/>
                 <a:cs typeface="Cambria" pitchFamily="34" charset="-120"/>
               </a:rPr>
-              <a:t>Convex optimisation</a:t>
+              <a:t>Kafka</a:t>
             </a:r>
             <a:endParaRPr lang="en-US" sz="1500" dirty="0"/>
           </a:p>
@@ -8349,13 +7977,13 @@
       </p:sp>
       <p:sp>
         <p:nvSpPr>
-          <p:cNvPr id="23" name="Text 16"/>
-          <p:cNvSpPr txBox="1"/>
-          <p:nvPr/>
-        </p:nvSpPr>
-        <p:spPr>
-          <a:xfrm>
-            <a:off x="7223760" y="3017520"/>
+          <p:cNvPr id="15" name="Text 10"/>
+          <p:cNvSpPr txBox="1"/>
+          <p:nvPr/>
+        </p:nvSpPr>
+        <p:spPr>
+          <a:xfrm>
+            <a:off x="3840480" y="3017520"/>
             <a:ext cx="1600200" cy="1097280"/>
           </a:xfrm>
           <a:prstGeom prst="rect">
@@ -8368,7 +7996,7 @@
           <a:bodyPr wrap="square" lIns="0" tIns="0" rIns="0" bIns="0" rtlCol="0" anchor="t"/>
           <a:lstStyle/>
           <a:p>
-            <a:pPr algn="ctr" indent="0" marL="0">
+            <a:pPr marL="0" indent="0" algn="ctr">
               <a:buNone/>
             </a:pPr>
             <a:r>
@@ -8380,7 +8008,7 @@
                 <a:ea typeface="Calibri" pitchFamily="34" charset="-122"/>
                 <a:cs typeface="Calibri" pitchFamily="34" charset="-120"/>
               </a:rPr>
-              <a:t>Advanced portfolio constraints</a:t>
+              <a:t>Streaming pipeline for real-time scale</a:t>
             </a:r>
             <a:endParaRPr lang="en-US" sz="1300" dirty="0"/>
           </a:p>
@@ -8388,30 +8016,113 @@
       </p:sp>
       <p:sp>
         <p:nvSpPr>
-          <p:cNvPr id="24" name="Text 17"/>
-          <p:cNvSpPr txBox="1"/>
-          <p:nvPr/>
-        </p:nvSpPr>
-        <p:spPr>
-          <a:xfrm>
-            <a:off x="457200" y="4754880"/>
-            <a:ext cx="2743200" cy="228600"/>
-          </a:xfrm>
-          <a:prstGeom prst="rect">
-            <a:avLst/>
-          </a:prstGeom>
-          <a:noFill/>
-          <a:ln/>
-        </p:spPr>
-        <p:txBody>
-          <a:bodyPr wrap="square" lIns="0" tIns="0" rIns="0" bIns="0" rtlCol="0" anchor="ctr"/>
-          <a:lstStyle/>
-          <a:p>
-            <a:pPr indent="0" marL="0">
-              <a:buNone/>
-            </a:pPr>
-            <a:r>
-              <a:rPr lang="en-US" sz="1000" dirty="0">
+          <p:cNvPr id="16" name="Shape 11"/>
+          <p:cNvSpPr/>
+          <p:nvPr/>
+        </p:nvSpPr>
+        <p:spPr>
+          <a:xfrm>
+            <a:off x="5989320" y="1463040"/>
+            <a:ext cx="822960" cy="822960"/>
+          </a:xfrm>
+          <a:prstGeom prst="ellipse">
+            <a:avLst/>
+          </a:prstGeom>
+          <a:solidFill>
+            <a:srgbClr val="0A1628"/>
+          </a:solidFill>
+          <a:ln/>
+        </p:spPr>
+      </p:sp>
+      <p:pic>
+        <p:nvPicPr>
+          <p:cNvPr id="17" name="Image 3" descr="preencoded.png"/>
+          <p:cNvPicPr>
+            <a:picLocks noChangeAspect="1"/>
+          </p:cNvPicPr>
+          <p:nvPr/>
+        </p:nvPicPr>
+        <p:blipFill>
+          <a:blip r:embed="rId6"/>
+          <a:stretch>
+            <a:fillRect/>
+          </a:stretch>
+        </p:blipFill>
+        <p:spPr>
+          <a:xfrm>
+            <a:off x="6190488" y="1664208"/>
+            <a:ext cx="420624" cy="420624"/>
+          </a:xfrm>
+          <a:prstGeom prst="rect">
+            <a:avLst/>
+          </a:prstGeom>
+        </p:spPr>
+      </p:pic>
+      <p:sp>
+        <p:nvSpPr>
+          <p:cNvPr id="18" name="Text 12"/>
+          <p:cNvSpPr txBox="1"/>
+          <p:nvPr/>
+        </p:nvSpPr>
+        <p:spPr>
+          <a:xfrm>
+            <a:off x="5532120" y="2468880"/>
+            <a:ext cx="1600200" cy="502920"/>
+          </a:xfrm>
+          <a:prstGeom prst="rect">
+            <a:avLst/>
+          </a:prstGeom>
+          <a:noFill/>
+          <a:ln/>
+        </p:spPr>
+        <p:txBody>
+          <a:bodyPr wrap="square" lIns="0" tIns="0" rIns="0" bIns="0" rtlCol="0" anchor="t"/>
+          <a:lstStyle/>
+          <a:p>
+            <a:pPr marL="0" indent="0" algn="ctr">
+              <a:buNone/>
+            </a:pPr>
+            <a:r>
+              <a:rPr lang="en-US" sz="1500" b="1" dirty="0">
+                <a:solidFill>
+                  <a:srgbClr val="0A1628"/>
+                </a:solidFill>
+                <a:latin typeface="Cambria" pitchFamily="34" charset="0"/>
+                <a:ea typeface="Cambria" pitchFamily="34" charset="-122"/>
+                <a:cs typeface="Cambria" pitchFamily="34" charset="-120"/>
+              </a:rPr>
+              <a:t>Fine-tuned FinBERT</a:t>
+            </a:r>
+            <a:endParaRPr lang="en-US" sz="1500" dirty="0"/>
+          </a:p>
+        </p:txBody>
+      </p:sp>
+      <p:sp>
+        <p:nvSpPr>
+          <p:cNvPr id="19" name="Text 13"/>
+          <p:cNvSpPr txBox="1"/>
+          <p:nvPr/>
+        </p:nvSpPr>
+        <p:spPr>
+          <a:xfrm>
+            <a:off x="5532120" y="3017520"/>
+            <a:ext cx="1600200" cy="1097280"/>
+          </a:xfrm>
+          <a:prstGeom prst="rect">
+            <a:avLst/>
+          </a:prstGeom>
+          <a:noFill/>
+          <a:ln/>
+        </p:spPr>
+        <p:txBody>
+          <a:bodyPr wrap="square" lIns="0" tIns="0" rIns="0" bIns="0" rtlCol="0" anchor="t"/>
+          <a:lstStyle/>
+          <a:p>
+            <a:pPr marL="0" indent="0" algn="ctr">
+              <a:buNone/>
+            </a:pPr>
+            <a:r>
+              <a:rPr lang="en-US" sz="1300" dirty="0">
                 <a:solidFill>
                   <a:srgbClr val="475569"/>
                 </a:solidFill>
@@ -8419,6 +8130,167 @@
                 <a:ea typeface="Calibri" pitchFamily="34" charset="-122"/>
                 <a:cs typeface="Calibri" pitchFamily="34" charset="-120"/>
               </a:rPr>
+              <a:t>Trained on proprietary data</a:t>
+            </a:r>
+            <a:endParaRPr lang="en-US" sz="1300" dirty="0"/>
+          </a:p>
+        </p:txBody>
+      </p:sp>
+      <p:sp>
+        <p:nvSpPr>
+          <p:cNvPr id="20" name="Shape 14"/>
+          <p:cNvSpPr/>
+          <p:nvPr/>
+        </p:nvSpPr>
+        <p:spPr>
+          <a:xfrm>
+            <a:off x="7680960" y="1463040"/>
+            <a:ext cx="822960" cy="822960"/>
+          </a:xfrm>
+          <a:prstGeom prst="ellipse">
+            <a:avLst/>
+          </a:prstGeom>
+          <a:solidFill>
+            <a:srgbClr val="0A1628"/>
+          </a:solidFill>
+          <a:ln/>
+        </p:spPr>
+      </p:sp>
+      <p:pic>
+        <p:nvPicPr>
+          <p:cNvPr id="21" name="Image 4" descr="preencoded.png"/>
+          <p:cNvPicPr>
+            <a:picLocks noChangeAspect="1"/>
+          </p:cNvPicPr>
+          <p:nvPr/>
+        </p:nvPicPr>
+        <p:blipFill>
+          <a:blip r:embed="rId7"/>
+          <a:stretch>
+            <a:fillRect/>
+          </a:stretch>
+        </p:blipFill>
+        <p:spPr>
+          <a:xfrm>
+            <a:off x="7882128" y="1664208"/>
+            <a:ext cx="420624" cy="420624"/>
+          </a:xfrm>
+          <a:prstGeom prst="rect">
+            <a:avLst/>
+          </a:prstGeom>
+        </p:spPr>
+      </p:pic>
+      <p:sp>
+        <p:nvSpPr>
+          <p:cNvPr id="22" name="Text 15"/>
+          <p:cNvSpPr txBox="1"/>
+          <p:nvPr/>
+        </p:nvSpPr>
+        <p:spPr>
+          <a:xfrm>
+            <a:off x="7223760" y="2468880"/>
+            <a:ext cx="1600200" cy="502920"/>
+          </a:xfrm>
+          <a:prstGeom prst="rect">
+            <a:avLst/>
+          </a:prstGeom>
+          <a:noFill/>
+          <a:ln/>
+        </p:spPr>
+        <p:txBody>
+          <a:bodyPr wrap="square" lIns="0" tIns="0" rIns="0" bIns="0" rtlCol="0" anchor="t"/>
+          <a:lstStyle/>
+          <a:p>
+            <a:pPr marL="0" indent="0" algn="ctr">
+              <a:buNone/>
+            </a:pPr>
+            <a:r>
+              <a:rPr lang="en-US" sz="1500" b="1" dirty="0">
+                <a:solidFill>
+                  <a:srgbClr val="0A1628"/>
+                </a:solidFill>
+                <a:latin typeface="Cambria" pitchFamily="34" charset="0"/>
+                <a:ea typeface="Cambria" pitchFamily="34" charset="-122"/>
+                <a:cs typeface="Cambria" pitchFamily="34" charset="-120"/>
+              </a:rPr>
+              <a:t>Convex optimisation</a:t>
+            </a:r>
+            <a:endParaRPr lang="en-US" sz="1500" dirty="0"/>
+          </a:p>
+        </p:txBody>
+      </p:sp>
+      <p:sp>
+        <p:nvSpPr>
+          <p:cNvPr id="23" name="Text 16"/>
+          <p:cNvSpPr txBox="1"/>
+          <p:nvPr/>
+        </p:nvSpPr>
+        <p:spPr>
+          <a:xfrm>
+            <a:off x="7223760" y="3017520"/>
+            <a:ext cx="1600200" cy="1097280"/>
+          </a:xfrm>
+          <a:prstGeom prst="rect">
+            <a:avLst/>
+          </a:prstGeom>
+          <a:noFill/>
+          <a:ln/>
+        </p:spPr>
+        <p:txBody>
+          <a:bodyPr wrap="square" lIns="0" tIns="0" rIns="0" bIns="0" rtlCol="0" anchor="t"/>
+          <a:lstStyle/>
+          <a:p>
+            <a:pPr marL="0" indent="0" algn="ctr">
+              <a:buNone/>
+            </a:pPr>
+            <a:r>
+              <a:rPr lang="en-US" sz="1300" dirty="0">
+                <a:solidFill>
+                  <a:srgbClr val="475569"/>
+                </a:solidFill>
+                <a:latin typeface="Calibri" pitchFamily="34" charset="0"/>
+                <a:ea typeface="Calibri" pitchFamily="34" charset="-122"/>
+                <a:cs typeface="Calibri" pitchFamily="34" charset="-120"/>
+              </a:rPr>
+              <a:t>Advanced portfolio constraints</a:t>
+            </a:r>
+            <a:endParaRPr lang="en-US" sz="1300" dirty="0"/>
+          </a:p>
+        </p:txBody>
+      </p:sp>
+      <p:sp>
+        <p:nvSpPr>
+          <p:cNvPr id="24" name="Text 17"/>
+          <p:cNvSpPr txBox="1"/>
+          <p:nvPr/>
+        </p:nvSpPr>
+        <p:spPr>
+          <a:xfrm>
+            <a:off x="457200" y="4754880"/>
+            <a:ext cx="2743200" cy="228600"/>
+          </a:xfrm>
+          <a:prstGeom prst="rect">
+            <a:avLst/>
+          </a:prstGeom>
+          <a:noFill/>
+          <a:ln/>
+        </p:spPr>
+        <p:txBody>
+          <a:bodyPr wrap="square" lIns="0" tIns="0" rIns="0" bIns="0" rtlCol="0" anchor="ctr"/>
+          <a:lstStyle/>
+          <a:p>
+            <a:pPr marL="0" indent="0">
+              <a:buNone/>
+            </a:pPr>
+            <a:r>
+              <a:rPr lang="en-US" sz="1000" dirty="0">
+                <a:solidFill>
+                  <a:srgbClr val="475569"/>
+                </a:solidFill>
+                <a:latin typeface="Calibri" pitchFamily="34" charset="0"/>
+                <a:ea typeface="Calibri" pitchFamily="34" charset="-122"/>
+                <a:cs typeface="Calibri" pitchFamily="34" charset="-120"/>
+              </a:rPr>
               <a:t>SentinelRisk</a:t>
             </a:r>
             <a:endParaRPr lang="en-US" sz="1000" dirty="0"/>
@@ -8446,7 +8318,7 @@
           <a:bodyPr wrap="square" lIns="0" tIns="0" rIns="0" bIns="0" rtlCol="0" anchor="ctr"/>
           <a:lstStyle/>
           <a:p>
-            <a:pPr algn="r" indent="0" marL="0">
+            <a:pPr marL="0" indent="0" algn="r">
               <a:buNone/>
             </a:pPr>
             <a:r>
@@ -8480,6 +8352,7 @@
         <a:solidFill>
           <a:srgbClr val="0A1628"/>
         </a:solidFill>
+        <a:effectLst/>
       </p:bgPr>
     </p:bg>
     <p:spTree>
@@ -8498,14 +8371,14 @@
       </p:grpSpPr>
       <p:pic>
         <p:nvPicPr>
-          <p:cNvPr id="2" name="Image 0" descr="preencoded.png">    </p:cNvPr>
+          <p:cNvPr id="2" name="Image 0" descr="preencoded.png"/>
           <p:cNvPicPr>
             <a:picLocks noChangeAspect="1"/>
           </p:cNvPicPr>
           <p:nvPr/>
         </p:nvPicPr>
         <p:blipFill>
-          <a:blip r:embed="rId1"/>
+          <a:blip r:embed="rId3"/>
           <a:stretch>
             <a:fillRect/>
           </a:stretch>
@@ -8541,7 +8414,7 @@
           <a:bodyPr wrap="square" lIns="0" tIns="0" rIns="0" bIns="0" rtlCol="0" anchor="ctr"/>
           <a:lstStyle/>
           <a:p>
-            <a:pPr indent="0" marL="0">
+            <a:pPr marL="0" indent="0">
               <a:buNone/>
             </a:pPr>
             <a:r>
@@ -8580,7 +8453,7 @@
           <a:bodyPr wrap="square" lIns="0" tIns="0" rIns="0" bIns="0" rtlCol="0" anchor="ctr"/>
           <a:lstStyle/>
           <a:p>
-            <a:pPr indent="0" marL="0">
+            <a:pPr marL="0" indent="0">
               <a:buNone/>
             </a:pPr>
             <a:r>
@@ -8641,7 +8514,7 @@
           <a:bodyPr wrap="square" lIns="0" tIns="0" rIns="0" bIns="0" rtlCol="0" anchor="ctr"/>
           <a:lstStyle/>
           <a:p>
-            <a:pPr algn="ctr" indent="0" marL="0">
+            <a:pPr marL="0" indent="0" algn="ctr">
               <a:buNone/>
             </a:pPr>
             <a:r>
@@ -8680,7 +8553,7 @@
           <a:bodyPr wrap="square" lIns="0" tIns="0" rIns="0" bIns="0" rtlCol="0" anchor="ctr"/>
           <a:lstStyle/>
           <a:p>
-            <a:pPr indent="0" marL="0">
+            <a:pPr marL="0" indent="0">
               <a:buNone/>
             </a:pPr>
             <a:r>
@@ -8999,4 +8872,299 @@
     </a:ext>
   </a:extLst>
 </a:theme>
+</file>
+
+<file path=ppt/theme/theme2.xml><?xml version="1.0" encoding="utf-8"?>
+<a:theme xmlns:a="http://schemas.openxmlformats.org/drawingml/2006/main" name="Office Theme">
+  <a:themeElements>
+    <a:clrScheme name="Office">
+      <a:dk1>
+        <a:sysClr val="windowText" lastClr="000000"/>
+      </a:dk1>
+      <a:lt1>
+        <a:sysClr val="window" lastClr="FFFFFF"/>
+      </a:lt1>
+      <a:dk2>
+        <a:srgbClr val="44546A"/>
+      </a:dk2>
+      <a:lt2>
+        <a:srgbClr val="E7E6E6"/>
+      </a:lt2>
+      <a:accent1>
+        <a:srgbClr val="4472C4"/>
+      </a:accent1>
+      <a:accent2>
+        <a:srgbClr val="ED7D31"/>
+      </a:accent2>
+      <a:accent3>
+        <a:srgbClr val="A5A5A5"/>
+      </a:accent3>
+      <a:accent4>
+        <a:srgbClr val="FFC000"/>
+      </a:accent4>
+      <a:accent5>
+        <a:srgbClr val="5B9BD5"/>
+      </a:accent5>
+      <a:accent6>
+        <a:srgbClr val="70AD47"/>
+      </a:accent6>
+      <a:hlink>
+        <a:srgbClr val="0563C1"/>
+      </a:hlink>
+      <a:folHlink>
+        <a:srgbClr val="954F72"/>
+      </a:folHlink>
+    </a:clrScheme>
+    <a:fontScheme name="Office">
+      <a:majorFont>
+        <a:latin typeface="Calibri Light" panose="020F0302020204030204"/>
+        <a:ea typeface=""/>
+        <a:cs typeface=""/>
+        <a:font script="Jpan" typeface="游ゴシック Light"/>
+        <a:font script="Hang" typeface="맑은 고딕"/>
+        <a:font script="Hans" typeface="等线 Light"/>
+        <a:font script="Hant" typeface="新細明體"/>
+        <a:font script="Arab" typeface="Times New Roman"/>
+        <a:font script="Hebr" typeface="Times New Roman"/>
+        <a:font script="Thai" typeface="Angsana New"/>
+        <a:font script="Ethi" typeface="Nyala"/>
+        <a:font script="Beng" typeface="Vrinda"/>
+        <a:font script="Gujr" typeface="Shruti"/>
+        <a:font script="Khmr" typeface="MoolBoran"/>
+        <a:font script="Knda" typeface="Tunga"/>
+        <a:font script="Guru" typeface="Raavi"/>
+        <a:font script="Cans" typeface="Euphemia"/>
+        <a:font script="Cher" typeface="Plantagenet Cherokee"/>
+        <a:font script="Yiii" typeface="Microsoft Yi Baiti"/>
+        <a:font script="Tibt" typeface="Microsoft Himalaya"/>
+        <a:font script="Thaa" typeface="MV Boli"/>
+        <a:font script="Deva" typeface="Mangal"/>
+        <a:font script="Telu" typeface="Gautami"/>
+        <a:font script="Taml" typeface="Latha"/>
+        <a:font script="Syrc" typeface="Estrangelo Edessa"/>
+        <a:font script="Orya" typeface="Kalinga"/>
+        <a:font script="Mlym" typeface="Kartika"/>
+        <a:font script="Laoo" typeface="DokChampa"/>
+        <a:font script="Sinh" typeface="Iskoola Pota"/>
+        <a:font script="Mong" typeface="Mongolian Baiti"/>
+        <a:font script="Viet" typeface="Times New Roman"/>
+        <a:font script="Uigh" typeface="Microsoft Uighur"/>
+        <a:font script="Geor" typeface="Sylfaen"/>
+        <a:font script="Armn" typeface="Arial"/>
+        <a:font script="Bugi" typeface="Leelawadee UI"/>
+        <a:font script="Bopo" typeface="Microsoft JhengHei"/>
+        <a:font script="Java" typeface="Javanese Text"/>
+        <a:font script="Lisu" typeface="Segoe UI"/>
+        <a:font script="Mymr" typeface="Myanmar Text"/>
+        <a:font script="Nkoo" typeface="Ebrima"/>
+        <a:font script="Olck" typeface="Nirmala UI"/>
+        <a:font script="Osma" typeface="Ebrima"/>
+        <a:font script="Phag" typeface="Phagspa"/>
+        <a:font script="Syrn" typeface="Estrangelo Edessa"/>
+        <a:font script="Syrj" typeface="Estrangelo Edessa"/>
+        <a:font script="Syre" typeface="Estrangelo Edessa"/>
+        <a:font script="Sora" typeface="Nirmala UI"/>
+        <a:font script="Tale" typeface="Microsoft Tai Le"/>
+        <a:font script="Talu" typeface="Microsoft New Tai Lue"/>
+        <a:font script="Tfng" typeface="Ebrima"/>
+      </a:majorFont>
+      <a:minorFont>
+        <a:latin typeface="Calibri" panose="020F0502020204030204"/>
+        <a:ea typeface=""/>
+        <a:cs typeface=""/>
+        <a:font script="Jpan" typeface="游ゴシック"/>
+        <a:font script="Hang" typeface="맑은 고딕"/>
+        <a:font script="Hans" typeface="等线"/>
+        <a:font script="Hant" typeface="新細明體"/>
+        <a:font script="Arab" typeface="Arial"/>
+        <a:font script="Hebr" typeface="Arial"/>
+        <a:font script="Thai" typeface="Cordia New"/>
+        <a:font script="Ethi" typeface="Nyala"/>
+        <a:font script="Beng" typeface="Vrinda"/>
+        <a:font script="Gujr" typeface="Shruti"/>
+        <a:font script="Khmr" typeface="DaunPenh"/>
+        <a:font script="Knda" typeface="Tunga"/>
+        <a:font script="Guru" typeface="Raavi"/>
+        <a:font script="Cans" typeface="Euphemia"/>
+        <a:font script="Cher" typeface="Plantagenet Cherokee"/>
+        <a:font script="Yiii" typeface="Microsoft Yi Baiti"/>
+        <a:font script="Tibt" typeface="Microsoft Himalaya"/>
+        <a:font script="Thaa" typeface="MV Boli"/>
+        <a:font script="Deva" typeface="Mangal"/>
+        <a:font script="Telu" typeface="Gautami"/>
+        <a:font script="Taml" typeface="Latha"/>
+        <a:font script="Syrc" typeface="Estrangelo Edessa"/>
+        <a:font script="Orya" typeface="Kalinga"/>
+        <a:font script="Mlym" typeface="Kartika"/>
+        <a:font script="Laoo" typeface="DokChampa"/>
+        <a:font script="Sinh" typeface="Iskoola Pota"/>
+        <a:font script="Mong" typeface="Mongolian Baiti"/>
+        <a:font script="Viet" typeface="Arial"/>
+        <a:font script="Uigh" typeface="Microsoft Uighur"/>
+        <a:font script="Geor" typeface="Sylfaen"/>
+        <a:font script="Armn" typeface="Arial"/>
+        <a:font script="Bugi" typeface="Leelawadee UI"/>
+        <a:font script="Bopo" typeface="Microsoft JhengHei"/>
+        <a:font script="Java" typeface="Javanese Text"/>
+        <a:font script="Lisu" typeface="Segoe UI"/>
+        <a:font script="Mymr" typeface="Myanmar Text"/>
+        <a:font script="Nkoo" typeface="Ebrima"/>
+        <a:font script="Olck" typeface="Nirmala UI"/>
+        <a:font script="Osma" typeface="Ebrima"/>
+        <a:font script="Phag" typeface="Phagspa"/>
+        <a:font script="Syrn" typeface="Estrangelo Edessa"/>
+        <a:font script="Syrj" typeface="Estrangelo Edessa"/>
+        <a:font script="Syre" typeface="Estrangelo Edessa"/>
+        <a:font script="Sora" typeface="Nirmala UI"/>
+        <a:font script="Tale" typeface="Microsoft Tai Le"/>
+        <a:font script="Talu" typeface="Microsoft New Tai Lue"/>
+        <a:font script="Tfng" typeface="Ebrima"/>
+      </a:minorFont>
+    </a:fontScheme>
+    <a:fmtScheme name="Office">
+      <a:fillStyleLst>
+        <a:solidFill>
+          <a:schemeClr val="phClr"/>
+        </a:solidFill>
+        <a:gradFill rotWithShape="1">
+          <a:gsLst>
+            <a:gs pos="0">
+              <a:schemeClr val="phClr">
+                <a:lumMod val="110000"/>
+                <a:satMod val="105000"/>
+                <a:tint val="67000"/>
+              </a:schemeClr>
+            </a:gs>
+            <a:gs pos="50000">
+              <a:schemeClr val="phClr">
+                <a:lumMod val="105000"/>
+                <a:satMod val="103000"/>
+                <a:tint val="73000"/>
+              </a:schemeClr>
+            </a:gs>
+            <a:gs pos="100000">
+              <a:schemeClr val="phClr">
+                <a:lumMod val="105000"/>
+                <a:satMod val="109000"/>
+                <a:tint val="81000"/>
+              </a:schemeClr>
+            </a:gs>
+          </a:gsLst>
+          <a:lin ang="5400000" scaled="0"/>
+        </a:gradFill>
+        <a:gradFill rotWithShape="1">
+          <a:gsLst>
+            <a:gs pos="0">
+              <a:schemeClr val="phClr">
+                <a:satMod val="103000"/>
+                <a:lumMod val="102000"/>
+                <a:tint val="94000"/>
+              </a:schemeClr>
+            </a:gs>
+            <a:gs pos="50000">
+              <a:schemeClr val="phClr">
+                <a:satMod val="110000"/>
+                <a:lumMod val="100000"/>
+                <a:shade val="100000"/>
+              </a:schemeClr>
+            </a:gs>
+            <a:gs pos="100000">
+              <a:schemeClr val="phClr">
+                <a:lumMod val="99000"/>
+                <a:satMod val="120000"/>
+                <a:shade val="78000"/>
+              </a:schemeClr>
+            </a:gs>
+          </a:gsLst>
+          <a:lin ang="5400000" scaled="0"/>
+        </a:gradFill>
+      </a:fillStyleLst>
+      <a:lnStyleLst>
+        <a:ln w="6350" cap="flat" cmpd="sng" algn="ctr">
+          <a:solidFill>
+            <a:schemeClr val="phClr"/>
+          </a:solidFill>
+          <a:prstDash val="solid"/>
+          <a:miter lim="800000"/>
+        </a:ln>
+        <a:ln w="12700" cap="flat" cmpd="sng" algn="ctr">
+          <a:solidFill>
+            <a:schemeClr val="phClr"/>
+          </a:solidFill>
+          <a:prstDash val="solid"/>
+          <a:miter lim="800000"/>
+        </a:ln>
+        <a:ln w="19050" cap="flat" cmpd="sng" algn="ctr">
+          <a:solidFill>
+            <a:schemeClr val="phClr"/>
+          </a:solidFill>
+          <a:prstDash val="solid"/>
+          <a:miter lim="800000"/>
+        </a:ln>
+      </a:lnStyleLst>
+      <a:effectStyleLst>
+        <a:effectStyle>
+          <a:effectLst/>
+        </a:effectStyle>
+        <a:effectStyle>
+          <a:effectLst/>
+        </a:effectStyle>
+        <a:effectStyle>
+          <a:effectLst>
+            <a:outerShdw blurRad="57150" dist="19050" dir="5400000" algn="ctr" rotWithShape="0">
+              <a:srgbClr val="000000">
+                <a:alpha val="63000"/>
+              </a:srgbClr>
+            </a:outerShdw>
+          </a:effectLst>
+        </a:effectStyle>
+      </a:effectStyleLst>
+      <a:bgFillStyleLst>
+        <a:solidFill>
+          <a:schemeClr val="phClr"/>
+        </a:solidFill>
+        <a:solidFill>
+          <a:schemeClr val="phClr">
+            <a:tint val="95000"/>
+            <a:satMod val="170000"/>
+          </a:schemeClr>
+        </a:solidFill>
+        <a:gradFill rotWithShape="1">
+          <a:gsLst>
+            <a:gs pos="0">
+              <a:schemeClr val="phClr">
+                <a:tint val="93000"/>
+                <a:satMod val="150000"/>
+                <a:shade val="98000"/>
+                <a:lumMod val="102000"/>
+              </a:schemeClr>
+            </a:gs>
+            <a:gs pos="50000">
+              <a:schemeClr val="phClr">
+                <a:tint val="98000"/>
+                <a:satMod val="130000"/>
+                <a:shade val="90000"/>
+                <a:lumMod val="103000"/>
+              </a:schemeClr>
+            </a:gs>
+            <a:gs pos="100000">
+              <a:schemeClr val="phClr">
+                <a:shade val="63000"/>
+                <a:satMod val="120000"/>
+              </a:schemeClr>
+            </a:gs>
+          </a:gsLst>
+          <a:lin ang="5400000" scaled="0"/>
+        </a:gradFill>
+      </a:bgFillStyleLst>
+    </a:fmtScheme>
+  </a:themeElements>
+  <a:objectDefaults/>
+  <a:extraClrSchemeLst/>
+  <a:extLst>
+    <a:ext uri="{05A4C25C-085E-4340-85A3-A5531E510DB2}">
+      <thm15:themeFamily xmlns:thm15="http://schemas.microsoft.com/office/thememl/2012/main" name="Office Theme" id="{62F939B6-93AF-4DB8-9C6B-D6C7DFDC589F}" vid="{4A3C46E8-61CC-4603-A589-7422A47A8E4A}"/>
+    </a:ext>
+  </a:extLst>
+</a:theme>
 </file>
</xml_diff>